<commit_message>
feat: phase 5 hardening, measured deck, PDF, gpu face 7x
</commit_message>
<xml_diff>
--- a/deck/Raksha_Hackathon2026_Final.pptx
+++ b/deck/Raksha_Hackathon2026_Final.pptx
@@ -5779,7 +5779,7 @@
                 </a:solidFill>
                 <a:latin typeface="Calibri"/>
               </a:rPr>
-              <a:t>• Tracking on CPU: </a:t>
+              <a:t>• Tracking measured: </a:t>
             </a:r>
             <a:r>
               <a:rPr sz="2400" b="0">
@@ -5788,7 +5788,7 @@
                 </a:solidFill>
                 <a:latin typeface="Calibri"/>
               </a:rPr>
-              <a:t>YOLOv8n plus ByteTrack 8 to 12 FPS on i5, 20 FPS with ONNX. Assoc under 1ms.</a:t>
+              <a:t>YOLOv8s plus ByteTrack 15 to 30 FPS on RTX 4050, 8 with full overlay. Assoc under 1ms.</a:t>
             </a:r>
           </a:p>
           <a:p>
@@ -5807,7 +5807,7 @@
                 </a:solidFill>
                 <a:latin typeface="Calibri"/>
               </a:rPr>
-              <a:t>• Face live: </a:t>
+              <a:t>• Face measured: </a:t>
             </a:r>
             <a:r>
               <a:rPr sz="2400" b="0">
@@ -5816,7 +5816,7 @@
                 </a:solidFill>
                 <a:latin typeface="Calibri"/>
               </a:rPr>
-              <a:t>ArcFace 99.5 percent LFW, 15ms per face. Faiss 10M vectors in 3.8ms.</a:t>
+              <a:t>buffalo_s 61ms steady on GPU, was 438ms on CPU. Faiss gallery instant under 50k IDs.</a:t>
             </a:r>
           </a:p>
           <a:p>
@@ -5844,7 +5844,7 @@
                 </a:solidFill>
                 <a:latin typeface="Calibri"/>
               </a:rPr>
-              <a:t>AURORA 94.3 percent, 13.8s early lead. Rule version proven in field.</a:t>
+              <a:t>AURORA 94.3 percent, 13.8s early lead. Our rule meter fired RED 1.2 plus on dense test.</a:t>
             </a:r>
           </a:p>
           <a:p>
@@ -5872,7 +5872,7 @@
                 </a:solidFill>
                 <a:latin typeface="Calibri"/>
               </a:rPr>
-              <a:t>Webcam plus 2 clips plus 20 faces. No GPU needed for demo.</a:t>
+              <a:t>Webcam plus clips plus enrolled faces. No extra hardware needed for demo.</a:t>
             </a:r>
           </a:p>
         </p:txBody>

</xml_diff>

<commit_message>
feat: real CCTV footage lineup + visual-first deck v2 (flowchart, FPS chart, live screenshots)
</commit_message>
<xml_diff>
--- a/deck/Raksha_Hackathon2026_Final.pptx
+++ b/deck/Raksha_Hackathon2026_Final.pptx
@@ -128,6 +128,946 @@
     </a:lvl9pPr>
   </p:defaultTextStyle>
 </p:presentation>
+</file>
+
+<file path=ppt/charts/chart1.xml><?xml version="1.0" encoding="utf-8"?>
+<c:chartSpace xmlns:c="http://schemas.openxmlformats.org/drawingml/2006/chart" xmlns:a="http://schemas.openxmlformats.org/drawingml/2006/main" xmlns:r="http://schemas.openxmlformats.org/officeDocument/2006/relationships">
+  <c:date1904 val="0"/>
+  <c:chart>
+    <c:title>
+      <c:tx>
+        <c:rich>
+          <a:bodyPr/>
+          <a:lstStyle/>
+          <a:p>
+            <a:r>
+              <a:rPr sz="2000"/>
+              <a:t>Tracking speed, frames per second</a:t>
+            </a:r>
+          </a:p>
+        </c:rich>
+      </c:tx>
+      <c:layout/>
+      <c:overlay val="0"/>
+    </c:title>
+    <c:autoTitleDeleted val="0"/>
+    <c:plotArea>
+      <c:barChart>
+        <c:barDir val="col"/>
+        <c:grouping val="clustered"/>
+        <c:ser>
+          <c:idx val="0"/>
+          <c:order val="0"/>
+          <c:tx>
+            <c:strRef>
+              <c:f>Sheet1!$B$1</c:f>
+              <c:strCache>
+                <c:ptCount val="1"/>
+                <c:pt idx="0">
+                  <c:v>FPS</c:v>
+                </c:pt>
+              </c:strCache>
+            </c:strRef>
+          </c:tx>
+          <c:spPr>
+            <a:solidFill>
+              <a:srgbClr val="1E2761"/>
+            </a:solidFill>
+          </c:spPr>
+          <c:cat>
+            <c:strRef>
+              <c:f>Sheet1!$A$2:$A$4</c:f>
+              <c:strCache>
+                <c:ptCount val="3"/>
+                <c:pt idx="0">
+                  <c:v>Concourse</c:v>
+                </c:pt>
+                <c:pt idx="1">
+                  <c:v>Crossing</c:v>
+                </c:pt>
+                <c:pt idx="2">
+                  <c:v>Temple</c:v>
+                </c:pt>
+              </c:strCache>
+            </c:strRef>
+          </c:cat>
+          <c:val>
+            <c:numRef>
+              <c:f>Sheet1!$B$2:$B$4</c:f>
+              <c:numCache>
+                <c:formatCode>General</c:formatCode>
+                <c:ptCount val="3"/>
+                <c:pt idx="0">
+                  <c:v>14.8</c:v>
+                </c:pt>
+                <c:pt idx="1">
+                  <c:v>41.2</c:v>
+                </c:pt>
+                <c:pt idx="2">
+                  <c:v>48.7</c:v>
+                </c:pt>
+              </c:numCache>
+            </c:numRef>
+          </c:val>
+        </c:ser>
+        <c:dLbls>
+          <c:txPr>
+            <a:bodyPr/>
+            <a:lstStyle/>
+            <a:p>
+              <a:pPr>
+                <a:defRPr sz="1400"/>
+              </a:pPr>
+            </a:p>
+          </c:txPr>
+          <c:dLblPos val="outEnd"/>
+          <c:showLegendKey val="0"/>
+          <c:showVal val="1"/>
+          <c:showCatName val="0"/>
+          <c:showSerName val="0"/>
+          <c:showPercent val="0"/>
+          <c:showBubbleSize val="0"/>
+          <c:showLeaderLines val="1"/>
+        </c:dLbls>
+        <c:axId val="-2068027336"/>
+        <c:axId val="-2113994440"/>
+      </c:barChart>
+      <c:catAx>
+        <c:axId val="-2068027336"/>
+        <c:scaling>
+          <c:orientation val="minMax"/>
+        </c:scaling>
+        <c:delete val="0"/>
+        <c:axPos val="b"/>
+        <c:majorTickMark val="out"/>
+        <c:minorTickMark val="none"/>
+        <c:tickLblPos val="nextTo"/>
+        <c:txPr>
+          <a:bodyPr/>
+          <a:lstStyle/>
+          <a:p>
+            <a:pPr>
+              <a:defRPr sz="1400"/>
+            </a:pPr>
+          </a:p>
+        </c:txPr>
+        <c:crossAx val="-2113994440"/>
+        <c:crosses val="autoZero"/>
+        <c:auto val="1"/>
+        <c:lblAlgn val="ctr"/>
+        <c:lblOffset val="100"/>
+        <c:noMultiLvlLbl val="0"/>
+      </c:catAx>
+      <c:valAx>
+        <c:axId val="-2113994440"/>
+        <c:scaling>
+          <c:max val="55.0"/>
+          <c:min val="0.0"/>
+        </c:scaling>
+        <c:delete val="0"/>
+        <c:axPos val="l"/>
+        <c:majorTickMark val="out"/>
+        <c:minorTickMark val="none"/>
+        <c:tickLblPos val="nextTo"/>
+        <c:txPr>
+          <a:bodyPr/>
+          <a:lstStyle/>
+          <a:p>
+            <a:pPr>
+              <a:defRPr sz="1400"/>
+            </a:pPr>
+          </a:p>
+        </c:txPr>
+        <c:crossAx val="-2068027336"/>
+        <c:crosses val="autoZero"/>
+      </c:valAx>
+    </c:plotArea>
+    <c:dispBlanksAs val="gap"/>
+  </c:chart>
+  <c:txPr>
+    <a:bodyPr/>
+    <a:lstStyle/>
+    <a:p>
+      <a:pPr>
+        <a:defRPr sz="1800"/>
+      </a:pPr>
+      <a:endParaRPr lang="en-US"/>
+    </a:p>
+  </c:txPr>
+  <c:externalData r:id="rId1">
+    <c:autoUpdate val="0"/>
+  </c:externalData>
+</c:chartSpace>
+</file>
+
+<file path=ppt/notesMasters/notesMaster1.xml><?xml version="1.0" encoding="utf-8"?>
+<p:notesMaster xmlns:a="http://schemas.openxmlformats.org/drawingml/2006/main" xmlns:p="http://schemas.openxmlformats.org/presentationml/2006/main" xmlns:r="http://schemas.openxmlformats.org/officeDocument/2006/relationships">
+  <p:cSld>
+    <p:bg>
+      <p:bgRef idx="1001">
+        <a:schemeClr val="bg1"/>
+      </p:bgRef>
+    </p:bg>
+    <p:spTree>
+      <p:nvGrpSpPr>
+        <p:cNvPr id="1" name=""/>
+        <p:cNvGrpSpPr/>
+        <p:nvPr/>
+      </p:nvGrpSpPr>
+      <p:grpSpPr>
+        <a:xfrm>
+          <a:off x="0" y="0"/>
+          <a:ext cx="0" cy="0"/>
+          <a:chOff x="0" y="0"/>
+          <a:chExt cx="0" cy="0"/>
+        </a:xfrm>
+      </p:grpSpPr>
+      <p:sp>
+        <p:nvSpPr>
+          <p:cNvPr id="2" name="Header Placeholder 1"/>
+          <p:cNvSpPr>
+            <a:spLocks noGrp="1"/>
+          </p:cNvSpPr>
+          <p:nvPr>
+            <p:ph type="hdr" sz="quarter"/>
+          </p:nvPr>
+        </p:nvSpPr>
+        <p:spPr>
+          <a:xfrm>
+            <a:off x="0" y="0"/>
+            <a:ext cx="2971800" cy="457200"/>
+          </a:xfrm>
+          <a:prstGeom prst="rect">
+            <a:avLst/>
+          </a:prstGeom>
+        </p:spPr>
+        <p:txBody>
+          <a:bodyPr vert="horz" lIns="91440" tIns="45720" rIns="91440" bIns="45720" rtlCol="0"/>
+          <a:lstStyle>
+            <a:lvl1pPr algn="l">
+              <a:defRPr sz="1200"/>
+            </a:lvl1pPr>
+          </a:lstStyle>
+          <a:p>
+            <a:endParaRPr lang="en-US"/>
+          </a:p>
+        </p:txBody>
+      </p:sp>
+      <p:sp>
+        <p:nvSpPr>
+          <p:cNvPr id="3" name="Date Placeholder 2"/>
+          <p:cNvSpPr>
+            <a:spLocks noGrp="1"/>
+          </p:cNvSpPr>
+          <p:nvPr>
+            <p:ph type="dt" idx="1"/>
+          </p:nvPr>
+        </p:nvSpPr>
+        <p:spPr>
+          <a:xfrm>
+            <a:off x="3884613" y="0"/>
+            <a:ext cx="2971800" cy="457200"/>
+          </a:xfrm>
+          <a:prstGeom prst="rect">
+            <a:avLst/>
+          </a:prstGeom>
+        </p:spPr>
+        <p:txBody>
+          <a:bodyPr vert="horz" lIns="91440" tIns="45720" rIns="91440" bIns="45720" rtlCol="0"/>
+          <a:lstStyle>
+            <a:lvl1pPr algn="r">
+              <a:defRPr sz="1200"/>
+            </a:lvl1pPr>
+          </a:lstStyle>
+          <a:p>
+            <a:fld id="{0F89C1C7-3DCD-1040-A9CF-14679D8B5DDD}" type="datetimeFigureOut">
+              <a:rPr lang="en-US" smtClean="0"/>
+              <a:t>10/17/16</a:t>
+            </a:fld>
+            <a:endParaRPr lang="en-US"/>
+          </a:p>
+        </p:txBody>
+      </p:sp>
+      <p:sp>
+        <p:nvSpPr>
+          <p:cNvPr id="4" name="Slide Image Placeholder 3"/>
+          <p:cNvSpPr>
+            <a:spLocks noGrp="1" noRot="1" noChangeAspect="1"/>
+          </p:cNvSpPr>
+          <p:nvPr>
+            <p:ph type="sldImg" idx="2"/>
+          </p:nvPr>
+        </p:nvSpPr>
+        <p:spPr>
+          <a:xfrm>
+            <a:off x="1143000" y="685800"/>
+            <a:ext cx="4572000" cy="3429000"/>
+          </a:xfrm>
+          <a:prstGeom prst="rect">
+            <a:avLst/>
+          </a:prstGeom>
+          <a:noFill/>
+          <a:ln w="12700">
+            <a:solidFill>
+              <a:prstClr val="black"/>
+            </a:solidFill>
+          </a:ln>
+        </p:spPr>
+        <p:txBody>
+          <a:bodyPr vert="horz" lIns="91440" tIns="45720" rIns="91440" bIns="45720" rtlCol="0" anchor="ctr"/>
+          <a:lstStyle/>
+          <a:p>
+            <a:endParaRPr lang="en-US"/>
+          </a:p>
+        </p:txBody>
+      </p:sp>
+      <p:sp>
+        <p:nvSpPr>
+          <p:cNvPr id="5" name="Notes Placeholder 4"/>
+          <p:cNvSpPr>
+            <a:spLocks noGrp="1"/>
+          </p:cNvSpPr>
+          <p:nvPr>
+            <p:ph type="body" sz="quarter" idx="3"/>
+          </p:nvPr>
+        </p:nvSpPr>
+        <p:spPr>
+          <a:xfrm>
+            <a:off x="685800" y="4343400"/>
+            <a:ext cx="5486400" cy="4114800"/>
+          </a:xfrm>
+          <a:prstGeom prst="rect">
+            <a:avLst/>
+          </a:prstGeom>
+        </p:spPr>
+        <p:txBody>
+          <a:bodyPr vert="horz" lIns="91440" tIns="45720" rIns="91440" bIns="45720" rtlCol="0"/>
+          <a:lstStyle/>
+          <a:p>
+            <a:pPr lvl="0"/>
+            <a:r>
+              <a:rPr lang="en-US" smtClean="0"/>
+              <a:t>Click to edit Master text styles</a:t>
+            </a:r>
+          </a:p>
+          <a:p>
+            <a:pPr lvl="1"/>
+            <a:r>
+              <a:rPr lang="en-US" smtClean="0"/>
+              <a:t>Second level</a:t>
+            </a:r>
+          </a:p>
+          <a:p>
+            <a:pPr lvl="2"/>
+            <a:r>
+              <a:rPr lang="en-US" smtClean="0"/>
+              <a:t>Third level</a:t>
+            </a:r>
+          </a:p>
+          <a:p>
+            <a:pPr lvl="3"/>
+            <a:r>
+              <a:rPr lang="en-US" smtClean="0"/>
+              <a:t>Fourth level</a:t>
+            </a:r>
+          </a:p>
+          <a:p>
+            <a:pPr lvl="4"/>
+            <a:r>
+              <a:rPr lang="en-US" smtClean="0"/>
+              <a:t>Fifth level</a:t>
+            </a:r>
+            <a:endParaRPr lang="en-US"/>
+          </a:p>
+        </p:txBody>
+      </p:sp>
+      <p:sp>
+        <p:nvSpPr>
+          <p:cNvPr id="6" name="Footer Placeholder 5"/>
+          <p:cNvSpPr>
+            <a:spLocks noGrp="1"/>
+          </p:cNvSpPr>
+          <p:nvPr>
+            <p:ph type="ftr" sz="quarter" idx="4"/>
+          </p:nvPr>
+        </p:nvSpPr>
+        <p:spPr>
+          <a:xfrm>
+            <a:off x="0" y="8685213"/>
+            <a:ext cx="2971800" cy="457200"/>
+          </a:xfrm>
+          <a:prstGeom prst="rect">
+            <a:avLst/>
+          </a:prstGeom>
+        </p:spPr>
+        <p:txBody>
+          <a:bodyPr vert="horz" lIns="91440" tIns="45720" rIns="91440" bIns="45720" rtlCol="0" anchor="b"/>
+          <a:lstStyle>
+            <a:lvl1pPr algn="l">
+              <a:defRPr sz="1200"/>
+            </a:lvl1pPr>
+          </a:lstStyle>
+          <a:p>
+            <a:endParaRPr lang="en-US"/>
+          </a:p>
+        </p:txBody>
+      </p:sp>
+      <p:sp>
+        <p:nvSpPr>
+          <p:cNvPr id="7" name="Slide Number Placeholder 6"/>
+          <p:cNvSpPr>
+            <a:spLocks noGrp="1"/>
+          </p:cNvSpPr>
+          <p:nvPr>
+            <p:ph type="sldNum" sz="quarter" idx="5"/>
+          </p:nvPr>
+        </p:nvSpPr>
+        <p:spPr>
+          <a:xfrm>
+            <a:off x="3884613" y="8685213"/>
+            <a:ext cx="2971800" cy="457200"/>
+          </a:xfrm>
+          <a:prstGeom prst="rect">
+            <a:avLst/>
+          </a:prstGeom>
+        </p:spPr>
+        <p:txBody>
+          <a:bodyPr vert="horz" lIns="91440" tIns="45720" rIns="91440" bIns="45720" rtlCol="0" anchor="b"/>
+          <a:lstStyle>
+            <a:lvl1pPr algn="r">
+              <a:defRPr sz="1200"/>
+            </a:lvl1pPr>
+          </a:lstStyle>
+          <a:p>
+            <a:fld id="{BB5E49A5-4136-284D-997B-48E1D791AD67}" type="slidenum">
+              <a:rPr lang="en-US" smtClean="0"/>
+              <a:t>‹#›</a:t>
+            </a:fld>
+            <a:endParaRPr lang="en-US"/>
+          </a:p>
+        </p:txBody>
+      </p:sp>
+    </p:spTree>
+    <p:extLst>
+      <p:ext uri="{BB962C8B-B14F-4D97-AF65-F5344CB8AC3E}">
+        <p14:creationId xmlns:p14="http://schemas.microsoft.com/office/powerpoint/2010/main" val="2623252185"/>
+      </p:ext>
+    </p:extLst>
+  </p:cSld>
+  <p:clrMap bg1="lt1" tx1="dk1" bg2="lt2" tx2="dk2" accent1="accent1" accent2="accent2" accent3="accent3" accent4="accent4" accent5="accent5" accent6="accent6" hlink="hlink" folHlink="folHlink"/>
+  <p:notesStyle>
+    <a:lvl1pPr marL="0" algn="l" defTabSz="457200" rtl="0" eaLnBrk="1" latinLnBrk="0" hangingPunct="1">
+      <a:defRPr sz="1200" kern="1200">
+        <a:solidFill>
+          <a:schemeClr val="tx1"/>
+        </a:solidFill>
+        <a:latin typeface="+mn-lt"/>
+        <a:ea typeface="+mn-ea"/>
+        <a:cs typeface="+mn-cs"/>
+      </a:defRPr>
+    </a:lvl1pPr>
+    <a:lvl2pPr marL="457200" algn="l" defTabSz="457200" rtl="0" eaLnBrk="1" latinLnBrk="0" hangingPunct="1">
+      <a:defRPr sz="1200" kern="1200">
+        <a:solidFill>
+          <a:schemeClr val="tx1"/>
+        </a:solidFill>
+        <a:latin typeface="+mn-lt"/>
+        <a:ea typeface="+mn-ea"/>
+        <a:cs typeface="+mn-cs"/>
+      </a:defRPr>
+    </a:lvl2pPr>
+    <a:lvl3pPr marL="914400" algn="l" defTabSz="457200" rtl="0" eaLnBrk="1" latinLnBrk="0" hangingPunct="1">
+      <a:defRPr sz="1200" kern="1200">
+        <a:solidFill>
+          <a:schemeClr val="tx1"/>
+        </a:solidFill>
+        <a:latin typeface="+mn-lt"/>
+        <a:ea typeface="+mn-ea"/>
+        <a:cs typeface="+mn-cs"/>
+      </a:defRPr>
+    </a:lvl3pPr>
+    <a:lvl4pPr marL="1371600" algn="l" defTabSz="457200" rtl="0" eaLnBrk="1" latinLnBrk="0" hangingPunct="1">
+      <a:defRPr sz="1200" kern="1200">
+        <a:solidFill>
+          <a:schemeClr val="tx1"/>
+        </a:solidFill>
+        <a:latin typeface="+mn-lt"/>
+        <a:ea typeface="+mn-ea"/>
+        <a:cs typeface="+mn-cs"/>
+      </a:defRPr>
+    </a:lvl4pPr>
+    <a:lvl5pPr marL="1828800" algn="l" defTabSz="457200" rtl="0" eaLnBrk="1" latinLnBrk="0" hangingPunct="1">
+      <a:defRPr sz="1200" kern="1200">
+        <a:solidFill>
+          <a:schemeClr val="tx1"/>
+        </a:solidFill>
+        <a:latin typeface="+mn-lt"/>
+        <a:ea typeface="+mn-ea"/>
+        <a:cs typeface="+mn-cs"/>
+      </a:defRPr>
+    </a:lvl5pPr>
+    <a:lvl6pPr marL="2286000" algn="l" defTabSz="457200" rtl="0" eaLnBrk="1" latinLnBrk="0" hangingPunct="1">
+      <a:defRPr sz="1200" kern="1200">
+        <a:solidFill>
+          <a:schemeClr val="tx1"/>
+        </a:solidFill>
+        <a:latin typeface="+mn-lt"/>
+        <a:ea typeface="+mn-ea"/>
+        <a:cs typeface="+mn-cs"/>
+      </a:defRPr>
+    </a:lvl6pPr>
+    <a:lvl7pPr marL="2743200" algn="l" defTabSz="457200" rtl="0" eaLnBrk="1" latinLnBrk="0" hangingPunct="1">
+      <a:defRPr sz="1200" kern="1200">
+        <a:solidFill>
+          <a:schemeClr val="tx1"/>
+        </a:solidFill>
+        <a:latin typeface="+mn-lt"/>
+        <a:ea typeface="+mn-ea"/>
+        <a:cs typeface="+mn-cs"/>
+      </a:defRPr>
+    </a:lvl7pPr>
+    <a:lvl8pPr marL="3200400" algn="l" defTabSz="457200" rtl="0" eaLnBrk="1" latinLnBrk="0" hangingPunct="1">
+      <a:defRPr sz="1200" kern="1200">
+        <a:solidFill>
+          <a:schemeClr val="tx1"/>
+        </a:solidFill>
+        <a:latin typeface="+mn-lt"/>
+        <a:ea typeface="+mn-ea"/>
+        <a:cs typeface="+mn-cs"/>
+      </a:defRPr>
+    </a:lvl8pPr>
+    <a:lvl9pPr marL="3657600" algn="l" defTabSz="457200" rtl="0" eaLnBrk="1" latinLnBrk="0" hangingPunct="1">
+      <a:defRPr sz="1200" kern="1200">
+        <a:solidFill>
+          <a:schemeClr val="tx1"/>
+        </a:solidFill>
+        <a:latin typeface="+mn-lt"/>
+        <a:ea typeface="+mn-ea"/>
+        <a:cs typeface="+mn-cs"/>
+      </a:defRPr>
+    </a:lvl9pPr>
+  </p:notesStyle>
+</p:notesMaster>
+</file>
+
+<file path=ppt/notesSlides/notesSlide1.xml><?xml version="1.0" encoding="utf-8"?>
+<p:notes xmlns:a="http://schemas.openxmlformats.org/drawingml/2006/main" xmlns:p="http://schemas.openxmlformats.org/presentationml/2006/main" xmlns:r="http://schemas.openxmlformats.org/officeDocument/2006/relationships">
+  <p:cSld>
+    <p:spTree>
+      <p:nvGrpSpPr>
+        <p:cNvPr id="1" name=""/>
+        <p:cNvGrpSpPr/>
+        <p:nvPr/>
+      </p:nvGrpSpPr>
+      <p:grpSpPr>
+        <a:xfrm>
+          <a:off x="0" y="0"/>
+          <a:ext cx="0" cy="0"/>
+          <a:chOff x="0" y="0"/>
+          <a:chExt cx="0" cy="0"/>
+        </a:xfrm>
+      </p:grpSpPr>
+      <p:sp>
+        <p:nvSpPr>
+          <p:cNvPr id="2" name="Slide Image Placeholder 1"/>
+          <p:cNvSpPr>
+            <a:spLocks noGrp="1"/>
+          </p:cNvSpPr>
+          <p:nvPr>
+            <p:ph type="sldImg" idx="2"/>
+          </p:nvPr>
+        </p:nvSpPr>
+        <p:spPr/>
+      </p:sp>
+      <p:sp>
+        <p:nvSpPr>
+          <p:cNvPr id="3" name="Notes Placeholder 2"/>
+          <p:cNvSpPr>
+            <a:spLocks noGrp="1"/>
+          </p:cNvSpPr>
+          <p:nvPr>
+            <p:ph type="body" idx="3" sz="quarter"/>
+          </p:nvPr>
+        </p:nvSpPr>
+        <p:spPr/>
+        <p:txBody>
+          <a:bodyPr/>
+          <a:lstStyle/>
+          <a:p>
+            <a:r>
+              <a:t>Team Raksha, problem 2: safety at large public events. Live demo on real station footage.</a:t>
+            </a:r>
+          </a:p>
+        </p:txBody>
+      </p:sp>
+      <p:sp>
+        <p:nvSpPr>
+          <p:cNvPr id="4" name="Slide Number Placeholder 3"/>
+          <p:cNvSpPr>
+            <a:spLocks noGrp="1"/>
+          </p:cNvSpPr>
+          <p:nvPr>
+            <p:ph type="sldNum" idx="5" sz="quarter"/>
+          </p:nvPr>
+        </p:nvSpPr>
+        <p:spPr/>
+      </p:sp>
+    </p:spTree>
+  </p:cSld>
+  <p:clrMapOvr>
+    <a:masterClrMapping/>
+  </p:clrMapOvr>
+</p:notes>
+</file>
+
+<file path=ppt/notesSlides/notesSlide2.xml><?xml version="1.0" encoding="utf-8"?>
+<p:notes xmlns:a="http://schemas.openxmlformats.org/drawingml/2006/main" xmlns:p="http://schemas.openxmlformats.org/presentationml/2006/main" xmlns:r="http://schemas.openxmlformats.org/officeDocument/2006/relationships">
+  <p:cSld>
+    <p:spTree>
+      <p:nvGrpSpPr>
+        <p:cNvPr id="1" name=""/>
+        <p:cNvGrpSpPr/>
+        <p:nvPr/>
+      </p:nvGrpSpPr>
+      <p:grpSpPr>
+        <a:xfrm>
+          <a:off x="0" y="0"/>
+          <a:ext cx="0" cy="0"/>
+          <a:chOff x="0" y="0"/>
+          <a:chExt cx="0" cy="0"/>
+        </a:xfrm>
+      </p:grpSpPr>
+      <p:sp>
+        <p:nvSpPr>
+          <p:cNvPr id="2" name="Slide Image Placeholder 1"/>
+          <p:cNvSpPr>
+            <a:spLocks noGrp="1"/>
+          </p:cNvSpPr>
+          <p:nvPr>
+            <p:ph type="sldImg" idx="2"/>
+          </p:nvPr>
+        </p:nvSpPr>
+        <p:spPr/>
+      </p:sp>
+      <p:sp>
+        <p:nvSpPr>
+          <p:cNvPr id="3" name="Notes Placeholder 2"/>
+          <p:cNvSpPr>
+            <a:spLocks noGrp="1"/>
+          </p:cNvSpPr>
+          <p:nvPr>
+            <p:ph type="body" idx="3" sz="quarter"/>
+          </p:nvPr>
+        </p:nvSpPr>
+        <p:spPr/>
+        <p:txBody>
+          <a:bodyPr/>
+          <a:lstStyle/>
+          <a:p>
+            <a:r>
+              <a:t>One screen replaces the 50-screen stare. Face appears, file pops in 0.4s. Zone turns yellow, guard diverts in under 1s. Numbers are measured on our RTX 4050 laptop, demo on public station footage.</a:t>
+            </a:r>
+          </a:p>
+        </p:txBody>
+      </p:sp>
+      <p:sp>
+        <p:nvSpPr>
+          <p:cNvPr id="4" name="Slide Number Placeholder 3"/>
+          <p:cNvSpPr>
+            <a:spLocks noGrp="1"/>
+          </p:cNvSpPr>
+          <p:nvPr>
+            <p:ph type="sldNum" idx="5" sz="quarter"/>
+          </p:nvPr>
+        </p:nvSpPr>
+        <p:spPr/>
+      </p:sp>
+    </p:spTree>
+  </p:cSld>
+  <p:clrMapOvr>
+    <a:masterClrMapping/>
+  </p:clrMapOvr>
+</p:notes>
+</file>
+
+<file path=ppt/notesSlides/notesSlide3.xml><?xml version="1.0" encoding="utf-8"?>
+<p:notes xmlns:a="http://schemas.openxmlformats.org/drawingml/2006/main" xmlns:p="http://schemas.openxmlformats.org/presentationml/2006/main" xmlns:r="http://schemas.openxmlformats.org/officeDocument/2006/relationships">
+  <p:cSld>
+    <p:spTree>
+      <p:nvGrpSpPr>
+        <p:cNvPr id="1" name=""/>
+        <p:cNvGrpSpPr/>
+        <p:nvPr/>
+      </p:nvGrpSpPr>
+      <p:grpSpPr>
+        <a:xfrm>
+          <a:off x="0" y="0"/>
+          <a:ext cx="0" cy="0"/>
+          <a:chOff x="0" y="0"/>
+          <a:chExt cx="0" cy="0"/>
+        </a:xfrm>
+      </p:grpSpPr>
+      <p:sp>
+        <p:nvSpPr>
+          <p:cNvPr id="2" name="Slide Image Placeholder 1"/>
+          <p:cNvSpPr>
+            <a:spLocks noGrp="1"/>
+          </p:cNvSpPr>
+          <p:nvPr>
+            <p:ph type="sldImg" idx="2"/>
+          </p:nvPr>
+        </p:nvSpPr>
+        <p:spPr/>
+      </p:sp>
+      <p:sp>
+        <p:nvSpPr>
+          <p:cNvPr id="3" name="Notes Placeholder 2"/>
+          <p:cNvSpPr>
+            <a:spLocks noGrp="1"/>
+          </p:cNvSpPr>
+          <p:nvPr>
+            <p:ph type="body" idx="3" sz="quarter"/>
+          </p:nvPr>
+        </p:nvSpPr>
+        <p:spPr/>
+        <p:txBody>
+          <a:bodyPr/>
+          <a:lstStyle/>
+          <a:p>
+            <a:r>
+              <a:t>Ingest zones the frame. YOLOv8 plus ByteTrack holds IDs through occlusion. Best-snapshot scoring gates faces, ArcFace plus Faiss matches the gallery, brain multiplies density by stillness by counterflow and pushes the alert.</a:t>
+            </a:r>
+          </a:p>
+        </p:txBody>
+      </p:sp>
+      <p:sp>
+        <p:nvSpPr>
+          <p:cNvPr id="4" name="Slide Number Placeholder 3"/>
+          <p:cNvSpPr>
+            <a:spLocks noGrp="1"/>
+          </p:cNvSpPr>
+          <p:nvPr>
+            <p:ph type="sldNum" idx="5" sz="quarter"/>
+          </p:nvPr>
+        </p:nvSpPr>
+        <p:spPr/>
+      </p:sp>
+    </p:spTree>
+  </p:cSld>
+  <p:clrMapOvr>
+    <a:masterClrMapping/>
+  </p:clrMapOvr>
+</p:notes>
+</file>
+
+<file path=ppt/notesSlides/notesSlide4.xml><?xml version="1.0" encoding="utf-8"?>
+<p:notes xmlns:a="http://schemas.openxmlformats.org/drawingml/2006/main" xmlns:p="http://schemas.openxmlformats.org/presentationml/2006/main" xmlns:r="http://schemas.openxmlformats.org/officeDocument/2006/relationships">
+  <p:cSld>
+    <p:spTree>
+      <p:nvGrpSpPr>
+        <p:cNvPr id="1" name=""/>
+        <p:cNvGrpSpPr/>
+        <p:nvPr/>
+      </p:nvGrpSpPr>
+      <p:grpSpPr>
+        <a:xfrm>
+          <a:off x="0" y="0"/>
+          <a:ext cx="0" cy="0"/>
+          <a:chOff x="0" y="0"/>
+          <a:chExt cx="0" cy="0"/>
+        </a:xfrm>
+      </p:grpSpPr>
+      <p:sp>
+        <p:nvSpPr>
+          <p:cNvPr id="2" name="Slide Image Placeholder 1"/>
+          <p:cNvSpPr>
+            <a:spLocks noGrp="1"/>
+          </p:cNvSpPr>
+          <p:nvPr>
+            <p:ph type="sldImg" idx="2"/>
+          </p:nvPr>
+        </p:nvSpPr>
+        <p:spPr/>
+      </p:sp>
+      <p:sp>
+        <p:nvSpPr>
+          <p:cNvPr id="3" name="Notes Placeholder 2"/>
+          <p:cNvSpPr>
+            <a:spLocks noGrp="1"/>
+          </p:cNvSpPr>
+          <p:nvPr>
+            <p:ph type="body" idx="3" sz="quarter"/>
+          </p:nvPr>
+        </p:nvSpPr>
+        <p:spPr/>
+        <p:txBody>
+          <a:bodyPr/>
+          <a:lstStyle/>
+          <a:p>
+            <a:r>
+              <a:t>All numbers measured on the team laptop, RTX 4050. Face engine 61ms steady on GPU. Stampede rule fired RED 1.2 plus on the dense test frame. Faiss gallery instant under 50k IDs. Fallback IoU tracker does 64 FPS if GPU is missing.</a:t>
+            </a:r>
+          </a:p>
+        </p:txBody>
+      </p:sp>
+      <p:sp>
+        <p:nvSpPr>
+          <p:cNvPr id="4" name="Slide Number Placeholder 3"/>
+          <p:cNvSpPr>
+            <a:spLocks noGrp="1"/>
+          </p:cNvSpPr>
+          <p:nvPr>
+            <p:ph type="sldNum" idx="5" sz="quarter"/>
+          </p:nvPr>
+        </p:nvSpPr>
+        <p:spPr/>
+      </p:sp>
+    </p:spTree>
+  </p:cSld>
+  <p:clrMapOvr>
+    <a:masterClrMapping/>
+  </p:clrMapOvr>
+</p:notes>
+</file>
+
+<file path=ppt/notesSlides/notesSlide5.xml><?xml version="1.0" encoding="utf-8"?>
+<p:notes xmlns:a="http://schemas.openxmlformats.org/drawingml/2006/main" xmlns:p="http://schemas.openxmlformats.org/presentationml/2006/main" xmlns:r="http://schemas.openxmlformats.org/officeDocument/2006/relationships">
+  <p:cSld>
+    <p:spTree>
+      <p:nvGrpSpPr>
+        <p:cNvPr id="1" name=""/>
+        <p:cNvGrpSpPr/>
+        <p:nvPr/>
+      </p:nvGrpSpPr>
+      <p:grpSpPr>
+        <a:xfrm>
+          <a:off x="0" y="0"/>
+          <a:ext cx="0" cy="0"/>
+          <a:chOff x="0" y="0"/>
+          <a:chExt cx="0" cy="0"/>
+        </a:xfrm>
+      </p:grpSpPr>
+      <p:sp>
+        <p:nvSpPr>
+          <p:cNvPr id="2" name="Slide Image Placeholder 1"/>
+          <p:cNvSpPr>
+            <a:spLocks noGrp="1"/>
+          </p:cNvSpPr>
+          <p:nvPr>
+            <p:ph type="sldImg" idx="2"/>
+          </p:nvPr>
+        </p:nvSpPr>
+        <p:spPr/>
+      </p:sp>
+      <p:sp>
+        <p:nvSpPr>
+          <p:cNvPr id="3" name="Notes Placeholder 2"/>
+          <p:cNvSpPr>
+            <a:spLocks noGrp="1"/>
+          </p:cNvSpPr>
+          <p:nvPr>
+            <p:ph type="body" idx="3" sz="quarter"/>
+          </p:nvPr>
+        </p:nvSpPr>
+        <p:spPr/>
+        <p:txBody>
+          <a:bodyPr/>
+          <a:lstStyle/>
+          <a:p>
+            <a:r>
+              <a:t>Fits mela, stadium, station, campus, mall. Pilot targets: 60s lead time, under 2s search, under 1s alert, audit-ready handoff zip.</a:t>
+            </a:r>
+          </a:p>
+        </p:txBody>
+      </p:sp>
+      <p:sp>
+        <p:nvSpPr>
+          <p:cNvPr id="4" name="Slide Number Placeholder 3"/>
+          <p:cNvSpPr>
+            <a:spLocks noGrp="1"/>
+          </p:cNvSpPr>
+          <p:nvPr>
+            <p:ph type="sldNum" idx="5" sz="quarter"/>
+          </p:nvPr>
+        </p:nvSpPr>
+        <p:spPr/>
+      </p:sp>
+    </p:spTree>
+  </p:cSld>
+  <p:clrMapOvr>
+    <a:masterClrMapping/>
+  </p:clrMapOvr>
+</p:notes>
+</file>
+
+<file path=ppt/notesSlides/notesSlide6.xml><?xml version="1.0" encoding="utf-8"?>
+<p:notes xmlns:a="http://schemas.openxmlformats.org/drawingml/2006/main" xmlns:p="http://schemas.openxmlformats.org/presentationml/2006/main" xmlns:r="http://schemas.openxmlformats.org/officeDocument/2006/relationships">
+  <p:cSld>
+    <p:spTree>
+      <p:nvGrpSpPr>
+        <p:cNvPr id="1" name=""/>
+        <p:cNvGrpSpPr/>
+        <p:nvPr/>
+      </p:nvGrpSpPr>
+      <p:grpSpPr>
+        <a:xfrm>
+          <a:off x="0" y="0"/>
+          <a:ext cx="0" cy="0"/>
+          <a:chOff x="0" y="0"/>
+          <a:chExt cx="0" cy="0"/>
+        </a:xfrm>
+      </p:grpSpPr>
+      <p:sp>
+        <p:nvSpPr>
+          <p:cNvPr id="2" name="Slide Image Placeholder 1"/>
+          <p:cNvSpPr>
+            <a:spLocks noGrp="1"/>
+          </p:cNvSpPr>
+          <p:nvPr>
+            <p:ph type="sldImg" idx="2"/>
+          </p:nvPr>
+        </p:nvSpPr>
+        <p:spPr/>
+      </p:sp>
+      <p:sp>
+        <p:nvSpPr>
+          <p:cNvPr id="3" name="Notes Placeholder 2"/>
+          <p:cNvSpPr>
+            <a:spLocks noGrp="1"/>
+          </p:cNvSpPr>
+          <p:nvPr>
+            <p:ph type="body" idx="3" sz="quarter"/>
+          </p:nvPr>
+        </p:nvSpPr>
+        <p:spPr/>
+        <p:txBody>
+          <a:bodyPr/>
+          <a:lstStyle/>
+          <a:p>
+            <a:r>
+              <a:t>Ethics are built in, not bolted on. Opt-in enrollment, blurred stored video, 7-day purge, append-only audit, no central ID linkage in the hackathon build.</a:t>
+            </a:r>
+          </a:p>
+        </p:txBody>
+      </p:sp>
+      <p:sp>
+        <p:nvSpPr>
+          <p:cNvPr id="4" name="Slide Number Placeholder 3"/>
+          <p:cNvSpPr>
+            <a:spLocks noGrp="1"/>
+          </p:cNvSpPr>
+          <p:nvPr>
+            <p:ph type="sldNum" idx="5" sz="quarter"/>
+          </p:nvPr>
+        </p:nvSpPr>
+        <p:spPr/>
+      </p:sp>
+    </p:spTree>
+  </p:cSld>
+  <p:clrMapOvr>
+    <a:masterClrMapping/>
+  </p:clrMapOvr>
+</p:notes>
 </file>
 
 <file path=ppt/slideLayouts/slideLayout1.xml><?xml version="1.0" encoding="utf-8"?>
@@ -4422,7 +5362,7 @@
           <a:noFill/>
         </p:spPr>
         <p:txBody>
-          <a:bodyPr wrap="square">
+          <a:bodyPr wrap="none">
             <a:spAutoFit/>
           </a:bodyPr>
           <a:lstStyle/>
@@ -4456,7 +5396,7 @@
           <a:noFill/>
         </p:spPr>
         <p:txBody>
-          <a:bodyPr wrap="square">
+          <a:bodyPr wrap="none">
             <a:spAutoFit/>
           </a:bodyPr>
           <a:lstStyle/>
@@ -4490,7 +5430,7 @@
           <a:noFill/>
         </p:spPr>
         <p:txBody>
-          <a:bodyPr wrap="square">
+          <a:bodyPr wrap="none">
             <a:spAutoFit/>
           </a:bodyPr>
           <a:lstStyle/>
@@ -4524,7 +5464,7 @@
           <a:noFill/>
         </p:spPr>
         <p:txBody>
-          <a:bodyPr wrap="square">
+          <a:bodyPr wrap="none">
             <a:spAutoFit/>
           </a:bodyPr>
           <a:lstStyle/>
@@ -4678,8 +5618,8 @@
         </p:nvSpPr>
         <p:spPr>
           <a:xfrm>
-            <a:off x="914400" y="2926080"/>
-            <a:ext cx="16459200" cy="4389120"/>
+            <a:off x="914400" y="2651760"/>
+            <a:ext cx="5120640" cy="3108960"/>
           </a:xfrm>
           <a:prstGeom prst="rect">
             <a:avLst/>
@@ -4693,143 +5633,205 @@
           <a:lstStyle/>
           <a:p>
             <a:pPr algn="l">
-              <a:spcBef>
-                <a:spcPts val="200"/>
-              </a:spcBef>
               <a:spcAft>
                 <a:spcPts val="1000"/>
               </a:spcAft>
             </a:pPr>
             <a:r>
-              <a:rPr sz="2600" b="1">
+              <a:rPr sz="3200" b="1">
                 <a:solidFill>
                   <a:srgbClr val="1E2761"/>
                 </a:solidFill>
                 <a:latin typeface="Calibri"/>
               </a:rPr>
-              <a:t>• RAKSHA Command Center: </a:t>
-            </a:r>
-            <a:r>
-              <a:rPr sz="2600" b="0">
+              <a:t>Know the crowd. Know the person. Stop the surge.</a:t>
+            </a:r>
+          </a:p>
+          <a:p>
+            <a:pPr algn="l">
+              <a:spcAft>
+                <a:spcPts val="1000"/>
+              </a:spcAft>
+            </a:pPr>
+            <a:r>
+              <a:rPr sz="2200" b="0">
                 <a:solidFill>
                   <a:srgbClr val="111111"/>
                 </a:solidFill>
                 <a:latin typeface="Calibri"/>
               </a:rPr>
-              <a:t>Know the crowd. Know the person. Stop the surge.</a:t>
+              <a:t>Live tracking plus instant person files.</a:t>
             </a:r>
           </a:p>
           <a:p>
             <a:pPr algn="l">
-              <a:spcBef>
-                <a:spcPts val="200"/>
-              </a:spcBef>
               <a:spcAft>
                 <a:spcPts val="1000"/>
               </a:spcAft>
             </a:pPr>
             <a:r>
-              <a:rPr sz="2600" b="1">
+              <a:rPr sz="2200" b="0">
+                <a:solidFill>
+                  <a:srgbClr val="111111"/>
+                </a:solidFill>
+                <a:latin typeface="Calibri"/>
+              </a:rPr>
+              <a:t>Surge warnings before the crush.</a:t>
+            </a:r>
+          </a:p>
+        </p:txBody>
+      </p:sp>
+      <p:pic>
+        <p:nvPicPr>
+          <p:cNvPr id="6" name="Picture 5" descr="deck_wall.png"/>
+          <p:cNvPicPr>
+            <a:picLocks noChangeAspect="1"/>
+          </p:cNvPicPr>
+          <p:nvPr/>
+        </p:nvPicPr>
+        <p:blipFill>
+          <a:blip r:embed="rId3"/>
+          <a:stretch>
+            <a:fillRect/>
+          </a:stretch>
+        </p:blipFill>
+        <p:spPr>
+          <a:xfrm>
+            <a:off x="6583680" y="2560320"/>
+            <a:ext cx="10789920" cy="6035040"/>
+          </a:xfrm>
+          <a:prstGeom prst="rect">
+            <a:avLst/>
+          </a:prstGeom>
+        </p:spPr>
+      </p:pic>
+      <p:sp>
+        <p:nvSpPr>
+          <p:cNvPr id="7" name="TextBox 6"/>
+          <p:cNvSpPr txBox="1"/>
+          <p:nvPr/>
+        </p:nvSpPr>
+        <p:spPr>
+          <a:xfrm>
+            <a:off x="914400" y="6583680"/>
+            <a:ext cx="3108960" cy="1005840"/>
+          </a:xfrm>
+          <a:prstGeom prst="rect">
+            <a:avLst/>
+          </a:prstGeom>
+          <a:noFill/>
+        </p:spPr>
+        <p:txBody>
+          <a:bodyPr wrap="square">
+            <a:spAutoFit/>
+          </a:bodyPr>
+          <a:lstStyle/>
+          <a:p>
+            <a:pPr algn="l">
+              <a:spcAft>
+                <a:spcPts val="0"/>
+              </a:spcAft>
+            </a:pPr>
+            <a:r>
+              <a:rPr sz="5400" b="1">
                 <a:solidFill>
                   <a:srgbClr val="1E2761"/>
                 </a:solidFill>
                 <a:latin typeface="Calibri"/>
               </a:rPr>
-              <a:t>• What: </a:t>
-            </a:r>
-            <a:r>
-              <a:rPr sz="2600" b="0">
+              <a:t>0.4s</a:t>
+            </a:r>
+          </a:p>
+        </p:txBody>
+      </p:sp>
+      <p:sp>
+        <p:nvSpPr>
+          <p:cNvPr id="8" name="TextBox 7"/>
+          <p:cNvSpPr txBox="1"/>
+          <p:nvPr/>
+        </p:nvSpPr>
+        <p:spPr>
+          <a:xfrm>
+            <a:off x="914400" y="7635240"/>
+            <a:ext cx="3108960" cy="731520"/>
+          </a:xfrm>
+          <a:prstGeom prst="rect">
+            <a:avLst/>
+          </a:prstGeom>
+          <a:noFill/>
+        </p:spPr>
+        <p:txBody>
+          <a:bodyPr wrap="square">
+            <a:spAutoFit/>
+          </a:bodyPr>
+          <a:lstStyle/>
+          <a:p>
+            <a:pPr algn="l">
+              <a:spcAft>
+                <a:spcPts val="0"/>
+              </a:spcAft>
+            </a:pPr>
+            <a:r>
+              <a:rPr sz="1800" b="0">
                 <a:solidFill>
-                  <a:srgbClr val="111111"/>
+                  <a:srgbClr val="5A5A5A"/>
                 </a:solidFill>
                 <a:latin typeface="Calibri"/>
               </a:rPr>
-              <a:t>Live multi-camera tracking plus instant person dossier plus stampede prevention</a:t>
-            </a:r>
-          </a:p>
+              <a:t>face to file pop</a:t>
+            </a:r>
+          </a:p>
+        </p:txBody>
+      </p:sp>
+      <p:sp>
+        <p:nvSpPr>
+          <p:cNvPr id="9" name="TextBox 8"/>
+          <p:cNvSpPr txBox="1"/>
+          <p:nvPr/>
+        </p:nvSpPr>
+        <p:spPr>
+          <a:xfrm>
+            <a:off x="2651760" y="6583680"/>
+            <a:ext cx="3108960" cy="1005840"/>
+          </a:xfrm>
+          <a:prstGeom prst="rect">
+            <a:avLst/>
+          </a:prstGeom>
+          <a:noFill/>
+        </p:spPr>
+        <p:txBody>
+          <a:bodyPr wrap="square">
+            <a:spAutoFit/>
+          </a:bodyPr>
+          <a:lstStyle/>
           <a:p>
             <a:pPr algn="l">
-              <a:spcBef>
-                <a:spcPts val="200"/>
-              </a:spcBef>
               <a:spcAft>
-                <a:spcPts val="1000"/>
+                <a:spcPts val="0"/>
               </a:spcAft>
             </a:pPr>
             <a:r>
-              <a:rPr sz="2600" b="1">
+              <a:rPr sz="5400" b="1">
                 <a:solidFill>
                   <a:srgbClr val="1E2761"/>
                 </a:solidFill>
                 <a:latin typeface="Calibri"/>
               </a:rPr>
-              <a:t>• Wow: </a:t>
-            </a:r>
-            <a:r>
-              <a:rPr sz="2600" b="0">
-                <a:solidFill>
-                  <a:srgbClr val="111111"/>
-                </a:solidFill>
-                <a:latin typeface="Calibri"/>
-              </a:rPr>
-              <a:t>Face appears, file pops in 0.4s. Zone RED, guard diverts in under 1s.</a:t>
-            </a:r>
-          </a:p>
-        </p:txBody>
-      </p:sp>
-      <p:sp>
-        <p:nvSpPr>
-          <p:cNvPr id="6" name="Rounded Rectangle 5"/>
-          <p:cNvSpPr/>
+              <a:t>&lt;1s</a:t>
+            </a:r>
+          </a:p>
+        </p:txBody>
+      </p:sp>
+      <p:sp>
+        <p:nvSpPr>
+          <p:cNvPr id="10" name="TextBox 9"/>
+          <p:cNvSpPr txBox="1"/>
           <p:nvPr/>
         </p:nvSpPr>
         <p:spPr>
           <a:xfrm>
-            <a:off x="914400" y="7315200"/>
-            <a:ext cx="5212080" cy="2286000"/>
-          </a:xfrm>
-          <a:prstGeom prst="roundRect">
-            <a:avLst/>
-          </a:prstGeom>
-          <a:solidFill>
-            <a:srgbClr val="EEF2FF"/>
-          </a:solidFill>
-          <a:ln>
-            <a:noFill/>
-          </a:ln>
-        </p:spPr>
-        <p:style>
-          <a:lnRef idx="1">
-            <a:schemeClr val="accent1"/>
-          </a:lnRef>
-          <a:fillRef idx="3">
-            <a:schemeClr val="accent1"/>
-          </a:fillRef>
-          <a:effectRef idx="2">
-            <a:schemeClr val="accent1"/>
-          </a:effectRef>
-          <a:fontRef idx="minor">
-            <a:schemeClr val="lt1"/>
-          </a:fontRef>
-        </p:style>
-        <p:txBody>
-          <a:bodyPr rtlCol="0" anchor="ctr"/>
-          <a:lstStyle/>
-          <a:p>
-            <a:pPr algn="ctr"/>
-          </a:p>
-        </p:txBody>
-      </p:sp>
-      <p:sp>
-        <p:nvSpPr>
-          <p:cNvPr id="7" name="TextBox 6"/>
-          <p:cNvSpPr txBox="1"/>
-          <p:nvPr/>
-        </p:nvSpPr>
-        <p:spPr>
-          <a:xfrm>
-            <a:off x="1188720" y="7589520"/>
-            <a:ext cx="4663440" cy="1737360"/>
+            <a:off x="2651760" y="7635240"/>
+            <a:ext cx="3108960" cy="731520"/>
           </a:xfrm>
           <a:prstGeom prst="rect">
             <a:avLst/>
@@ -4842,87 +5844,72 @@
           </a:bodyPr>
           <a:lstStyle/>
           <a:p>
-            <a:r>
-              <a:rPr sz="2200" b="1">
+            <a:pPr algn="l">
+              <a:spcAft>
+                <a:spcPts val="0"/>
+              </a:spcAft>
+            </a:pPr>
+            <a:r>
+              <a:rPr sz="1800" b="0">
+                <a:solidFill>
+                  <a:srgbClr val="5A5A5A"/>
+                </a:solidFill>
+                <a:latin typeface="Calibri"/>
+              </a:rPr>
+              <a:t>yellow to guard</a:t>
+            </a:r>
+          </a:p>
+        </p:txBody>
+      </p:sp>
+      <p:sp>
+        <p:nvSpPr>
+          <p:cNvPr id="11" name="TextBox 10"/>
+          <p:cNvSpPr txBox="1"/>
+          <p:nvPr/>
+        </p:nvSpPr>
+        <p:spPr>
+          <a:xfrm>
+            <a:off x="4206240" y="6583680"/>
+            <a:ext cx="3108960" cy="1005840"/>
+          </a:xfrm>
+          <a:prstGeom prst="rect">
+            <a:avLst/>
+          </a:prstGeom>
+          <a:noFill/>
+        </p:spPr>
+        <p:txBody>
+          <a:bodyPr wrap="square">
+            <a:spAutoFit/>
+          </a:bodyPr>
+          <a:lstStyle/>
+          <a:p>
+            <a:pPr algn="l">
+              <a:spcAft>
+                <a:spcPts val="0"/>
+              </a:spcAft>
+            </a:pPr>
+            <a:r>
+              <a:rPr sz="5400" b="1">
                 <a:solidFill>
                   <a:srgbClr val="1E2761"/>
                 </a:solidFill>
                 <a:latin typeface="Calibri"/>
               </a:rPr>
-              <a:t>Live Tracking</a:t>
-            </a:r>
-          </a:p>
-          <a:p>
-            <a:pPr>
-              <a:spcBef>
-                <a:spcPts val="800"/>
-              </a:spcBef>
-            </a:pPr>
-            <a:r>
-              <a:rPr sz="1900">
-                <a:solidFill>
-                  <a:srgbClr val="111111"/>
-                </a:solidFill>
-                <a:latin typeface="Calibri"/>
-              </a:rPr>
-              <a:t>YOLOv8 plus ByteTrack IDs survive occlusion and cross-cam ReID</a:t>
-            </a:r>
-          </a:p>
-        </p:txBody>
-      </p:sp>
-      <p:sp>
-        <p:nvSpPr>
-          <p:cNvPr id="8" name="Rounded Rectangle 7"/>
-          <p:cNvSpPr/>
+              <a:t>15</a:t>
+            </a:r>
+          </a:p>
+        </p:txBody>
+      </p:sp>
+      <p:sp>
+        <p:nvSpPr>
+          <p:cNvPr id="12" name="TextBox 11"/>
+          <p:cNvSpPr txBox="1"/>
           <p:nvPr/>
         </p:nvSpPr>
         <p:spPr>
           <a:xfrm>
-            <a:off x="6537960" y="7315200"/>
-            <a:ext cx="5212080" cy="2286000"/>
-          </a:xfrm>
-          <a:prstGeom prst="roundRect">
-            <a:avLst/>
-          </a:prstGeom>
-          <a:solidFill>
-            <a:srgbClr val="EEF2FF"/>
-          </a:solidFill>
-          <a:ln>
-            <a:noFill/>
-          </a:ln>
-        </p:spPr>
-        <p:style>
-          <a:lnRef idx="1">
-            <a:schemeClr val="accent1"/>
-          </a:lnRef>
-          <a:fillRef idx="3">
-            <a:schemeClr val="accent1"/>
-          </a:fillRef>
-          <a:effectRef idx="2">
-            <a:schemeClr val="accent1"/>
-          </a:effectRef>
-          <a:fontRef idx="minor">
-            <a:schemeClr val="lt1"/>
-          </a:fontRef>
-        </p:style>
-        <p:txBody>
-          <a:bodyPr rtlCol="0" anchor="ctr"/>
-          <a:lstStyle/>
-          <a:p>
-            <a:pPr algn="ctr"/>
-          </a:p>
-        </p:txBody>
-      </p:sp>
-      <p:sp>
-        <p:nvSpPr>
-          <p:cNvPr id="9" name="TextBox 8"/>
-          <p:cNvSpPr txBox="1"/>
-          <p:nvPr/>
-        </p:nvSpPr>
-        <p:spPr>
-          <a:xfrm>
-            <a:off x="6812280" y="7589520"/>
-            <a:ext cx="4663440" cy="1737360"/>
+            <a:off x="4206240" y="7635240"/>
+            <a:ext cx="3108960" cy="731520"/>
           </a:xfrm>
           <a:prstGeom prst="rect">
             <a:avLst/>
@@ -4935,87 +5922,33 @@
           </a:bodyPr>
           <a:lstStyle/>
           <a:p>
-            <a:r>
-              <a:rPr sz="2200" b="1">
+            <a:pPr algn="l">
+              <a:spcAft>
+                <a:spcPts val="0"/>
+              </a:spcAft>
+            </a:pPr>
+            <a:r>
+              <a:rPr sz="1800" b="0">
                 <a:solidFill>
-                  <a:srgbClr val="1E2761"/>
+                  <a:srgbClr val="5A5A5A"/>
                 </a:solidFill>
                 <a:latin typeface="Calibri"/>
               </a:rPr>
-              <a:t>Instant Dossier</a:t>
-            </a:r>
-          </a:p>
-          <a:p>
-            <a:pPr>
-              <a:spcBef>
-                <a:spcPts val="800"/>
-              </a:spcBef>
-            </a:pPr>
-            <a:r>
-              <a:rPr sz="1900">
-                <a:solidFill>
-                  <a:srgbClr val="111111"/>
-                </a:solidFill>
-                <a:latin typeface="Calibri"/>
-              </a:rPr>
-              <a:t>ArcFace 512-D plus age, gender, clothing and trajectory map</a:t>
-            </a:r>
-          </a:p>
-        </p:txBody>
-      </p:sp>
-      <p:sp>
-        <p:nvSpPr>
-          <p:cNvPr id="10" name="Rounded Rectangle 9"/>
-          <p:cNvSpPr/>
+              <a:t>fps live wall</a:t>
+            </a:r>
+          </a:p>
+        </p:txBody>
+      </p:sp>
+      <p:sp>
+        <p:nvSpPr>
+          <p:cNvPr id="13" name="TextBox 12"/>
+          <p:cNvSpPr txBox="1"/>
           <p:nvPr/>
         </p:nvSpPr>
         <p:spPr>
           <a:xfrm>
-            <a:off x="12161520" y="7315200"/>
-            <a:ext cx="5212080" cy="2286000"/>
-          </a:xfrm>
-          <a:prstGeom prst="roundRect">
-            <a:avLst/>
-          </a:prstGeom>
-          <a:solidFill>
-            <a:srgbClr val="EEF2FF"/>
-          </a:solidFill>
-          <a:ln>
-            <a:noFill/>
-          </a:ln>
-        </p:spPr>
-        <p:style>
-          <a:lnRef idx="1">
-            <a:schemeClr val="accent1"/>
-          </a:lnRef>
-          <a:fillRef idx="3">
-            <a:schemeClr val="accent1"/>
-          </a:fillRef>
-          <a:effectRef idx="2">
-            <a:schemeClr val="accent1"/>
-          </a:effectRef>
-          <a:fontRef idx="minor">
-            <a:schemeClr val="lt1"/>
-          </a:fontRef>
-        </p:style>
-        <p:txBody>
-          <a:bodyPr rtlCol="0" anchor="ctr"/>
-          <a:lstStyle/>
-          <a:p>
-            <a:pPr algn="ctr"/>
-          </a:p>
-        </p:txBody>
-      </p:sp>
-      <p:sp>
-        <p:nvSpPr>
-          <p:cNvPr id="11" name="TextBox 10"/>
-          <p:cNvSpPr txBox="1"/>
-          <p:nvPr/>
-        </p:nvSpPr>
-        <p:spPr>
-          <a:xfrm>
-            <a:off x="12435840" y="7589520"/>
-            <a:ext cx="4663440" cy="1737360"/>
+            <a:off x="6583680" y="8778240"/>
+            <a:ext cx="10789920" cy="548640"/>
           </a:xfrm>
           <a:prstGeom prst="rect">
             <a:avLst/>
@@ -5028,30 +5961,19 @@
           </a:bodyPr>
           <a:lstStyle/>
           <a:p>
-            <a:r>
-              <a:rPr sz="2200" b="1">
+            <a:pPr algn="l">
+              <a:spcAft>
+                <a:spcPts val="600"/>
+              </a:spcAft>
+            </a:pPr>
+            <a:r>
+              <a:rPr sz="1500" b="0">
                 <a:solidFill>
-                  <a:srgbClr val="1E2761"/>
+                  <a:srgbClr val="5A5A5A"/>
                 </a:solidFill>
                 <a:latin typeface="Calibri"/>
               </a:rPr>
-              <a:t>Proactive Action</a:t>
-            </a:r>
-          </a:p>
-          <a:p>
-            <a:pPr>
-              <a:spcBef>
-                <a:spcPts val="800"/>
-              </a:spcBef>
-            </a:pPr>
-            <a:r>
-              <a:rPr sz="1900">
-                <a:solidFill>
-                  <a:srgbClr val="111111"/>
-                </a:solidFill>
-                <a:latin typeface="Calibri"/>
-              </a:rPr>
-              <a:t>Density times stillness times counterflow equals risk meter</a:t>
+              <a:t>Above: the live wall on real station footage.</a:t>
             </a:r>
           </a:p>
         </p:txBody>
@@ -5194,155 +6116,20 @@
       </p:sp>
       <p:sp>
         <p:nvSpPr>
-          <p:cNvPr id="5" name="TextBox 4"/>
-          <p:cNvSpPr txBox="1"/>
+          <p:cNvPr id="5" name="Chevron 4"/>
+          <p:cNvSpPr/>
           <p:nvPr/>
         </p:nvSpPr>
         <p:spPr>
           <a:xfrm>
-            <a:off x="914400" y="2743200"/>
-            <a:ext cx="16459200" cy="4389120"/>
-          </a:xfrm>
-          <a:prstGeom prst="rect">
-            <a:avLst/>
-          </a:prstGeom>
-          <a:noFill/>
-        </p:spPr>
-        <p:txBody>
-          <a:bodyPr wrap="square">
-            <a:spAutoFit/>
-          </a:bodyPr>
-          <a:lstStyle/>
-          <a:p>
-            <a:pPr algn="l">
-              <a:spcBef>
-                <a:spcPts val="200"/>
-              </a:spcBef>
-              <a:spcAft>
-                <a:spcPts val="1000"/>
-              </a:spcAft>
-            </a:pPr>
-            <a:r>
-              <a:rPr sz="2400" b="1">
-                <a:solidFill>
-                  <a:srgbClr val="1E2761"/>
-                </a:solidFill>
-                <a:latin typeface="Calibri"/>
-              </a:rPr>
-              <a:t>• Ingest: </a:t>
-            </a:r>
-            <a:r>
-              <a:rPr sz="2400" b="0">
-                <a:solidFill>
-                  <a:srgbClr val="111111"/>
-                </a:solidFill>
-                <a:latin typeface="Calibri"/>
-              </a:rPr>
-              <a:t>RTSP, webcam, video file plus zone polygons. 720p and frame-skip 2 for CPU speed.</a:t>
-            </a:r>
-          </a:p>
-          <a:p>
-            <a:pPr algn="l">
-              <a:spcBef>
-                <a:spcPts val="200"/>
-              </a:spcBef>
-              <a:spcAft>
-                <a:spcPts val="1000"/>
-              </a:spcAft>
-            </a:pPr>
-            <a:r>
-              <a:rPr sz="2400" b="1">
-                <a:solidFill>
-                  <a:srgbClr val="1E2761"/>
-                </a:solidFill>
-                <a:latin typeface="Calibri"/>
-              </a:rPr>
-              <a:t>• Detect plus Track: </a:t>
-            </a:r>
-            <a:r>
-              <a:rPr sz="2400" b="0">
-                <a:solidFill>
-                  <a:srgbClr val="111111"/>
-                </a:solidFill>
-                <a:latin typeface="Calibri"/>
-              </a:rPr>
-              <a:t>YOLOv8n plus ByteTrack persist. OSNet ReID plus Hungarian for global ID.</a:t>
-            </a:r>
-          </a:p>
-          <a:p>
-            <a:pPr algn="l">
-              <a:spcBef>
-                <a:spcPts val="200"/>
-              </a:spcBef>
-              <a:spcAft>
-                <a:spcPts val="1000"/>
-              </a:spcAft>
-            </a:pPr>
-            <a:r>
-              <a:rPr sz="2400" b="1">
-                <a:solidFill>
-                  <a:srgbClr val="1E2761"/>
-                </a:solidFill>
-                <a:latin typeface="Calibri"/>
-              </a:rPr>
-              <a:t>• Face plus Attributes: </a:t>
-            </a:r>
-            <a:r>
-              <a:rPr sz="2400" b="0">
-                <a:solidFill>
-                  <a:srgbClr val="111111"/>
-                </a:solidFill>
-                <a:latin typeface="Calibri"/>
-              </a:rPr>
-              <a:t>Best-snapshot scoring for blur and pose. ArcFace plus clothing and age.</a:t>
-            </a:r>
-          </a:p>
-          <a:p>
-            <a:pPr algn="l">
-              <a:spcBef>
-                <a:spcPts val="200"/>
-              </a:spcBef>
-              <a:spcAft>
-                <a:spcPts val="1000"/>
-              </a:spcAft>
-            </a:pPr>
-            <a:r>
-              <a:rPr sz="2400" b="1">
-                <a:solidFill>
-                  <a:srgbClr val="1E2761"/>
-                </a:solidFill>
-                <a:latin typeface="Calibri"/>
-              </a:rPr>
-              <a:t>• Search plus Analyze: </a:t>
-            </a:r>
-            <a:r>
-              <a:rPr sz="2400" b="0">
-                <a:solidFill>
-                  <a:srgbClr val="111111"/>
-                </a:solidFill>
-                <a:latin typeface="Calibri"/>
-              </a:rPr>
-              <a:t>Faiss one-person-one-file. Density, flow and bottleneck alerts under 1s.</a:t>
-            </a:r>
-          </a:p>
-        </p:txBody>
-      </p:sp>
-      <p:sp>
-        <p:nvSpPr>
-          <p:cNvPr id="6" name="Rounded Rectangle 5"/>
-          <p:cNvSpPr/>
-          <p:nvPr/>
-        </p:nvSpPr>
-        <p:spPr>
-          <a:xfrm>
-            <a:off x="914400" y="7315200"/>
-            <a:ext cx="5212080" cy="2286000"/>
-          </a:xfrm>
-          <a:prstGeom prst="roundRect">
+            <a:off x="731520" y="2834640"/>
+            <a:ext cx="2880360" cy="1554480"/>
+          </a:xfrm>
+          <a:prstGeom prst="chevron">
             <a:avLst/>
           </a:prstGeom>
           <a:solidFill>
-            <a:srgbClr val="EEF2FF"/>
+            <a:srgbClr val="1E2761"/>
           </a:solidFill>
           <a:ln>
             <a:noFill/>
@@ -5363,23 +6150,32 @@
           </a:fontRef>
         </p:style>
         <p:txBody>
-          <a:bodyPr rtlCol="0" anchor="ctr"/>
+          <a:bodyPr rtlCol="0" anchor="ctr" wrap="square"/>
           <a:lstStyle/>
           <a:p>
             <a:pPr algn="ctr"/>
-          </a:p>
-        </p:txBody>
-      </p:sp>
-      <p:sp>
-        <p:nvSpPr>
-          <p:cNvPr id="7" name="TextBox 6"/>
+            <a:r>
+              <a:rPr sz="2200" b="1">
+                <a:solidFill>
+                  <a:srgbClr val="FFFFFF"/>
+                </a:solidFill>
+                <a:latin typeface="Calibri"/>
+              </a:rPr>
+              <a:t>Ingest</a:t>
+            </a:r>
+          </a:p>
+        </p:txBody>
+      </p:sp>
+      <p:sp>
+        <p:nvSpPr>
+          <p:cNvPr id="6" name="TextBox 5"/>
           <p:cNvSpPr txBox="1"/>
           <p:nvPr/>
         </p:nvSpPr>
         <p:spPr>
           <a:xfrm>
-            <a:off x="1188720" y="7589520"/>
-            <a:ext cx="4663440" cy="1737360"/>
+            <a:off x="731520" y="4480559"/>
+            <a:ext cx="2880360" cy="914400"/>
           </a:xfrm>
           <a:prstGeom prst="rect">
             <a:avLst/>
@@ -5392,50 +6188,39 @@
           </a:bodyPr>
           <a:lstStyle/>
           <a:p>
-            <a:r>
-              <a:rPr sz="2200" b="1">
+            <a:pPr algn="ctr">
+              <a:spcAft>
+                <a:spcPts val="600"/>
+              </a:spcAft>
+            </a:pPr>
+            <a:r>
+              <a:rPr sz="1600" b="0">
                 <a:solidFill>
-                  <a:srgbClr val="1E2761"/>
+                  <a:srgbClr val="5A5A5A"/>
                 </a:solidFill>
                 <a:latin typeface="Calibri"/>
               </a:rPr>
-              <a:t>Pipeline</a:t>
-            </a:r>
-          </a:p>
-          <a:p>
-            <a:pPr>
-              <a:spcBef>
-                <a:spcPts val="800"/>
-              </a:spcBef>
-            </a:pPr>
-            <a:r>
-              <a:rPr sz="1900">
-                <a:solidFill>
-                  <a:srgbClr val="111111"/>
-                </a:solidFill>
-                <a:latin typeface="Calibri"/>
-              </a:rPr>
-              <a:t>Ingest to Track to Face to Match to Analyze to Act</a:t>
-            </a:r>
-          </a:p>
-        </p:txBody>
-      </p:sp>
-      <p:sp>
-        <p:nvSpPr>
-          <p:cNvPr id="8" name="Rounded Rectangle 7"/>
+              <a:t>RTSP, file, zones</a:t>
+            </a:r>
+          </a:p>
+        </p:txBody>
+      </p:sp>
+      <p:sp>
+        <p:nvSpPr>
+          <p:cNvPr id="7" name="Chevron 6"/>
           <p:cNvSpPr/>
           <p:nvPr/>
         </p:nvSpPr>
         <p:spPr>
           <a:xfrm>
-            <a:off x="6537960" y="7315200"/>
-            <a:ext cx="5212080" cy="2286000"/>
-          </a:xfrm>
-          <a:prstGeom prst="roundRect">
+            <a:off x="3200400" y="2834640"/>
+            <a:ext cx="2880360" cy="1554480"/>
+          </a:xfrm>
+          <a:prstGeom prst="chevron">
             <a:avLst/>
           </a:prstGeom>
           <a:solidFill>
-            <a:srgbClr val="EEF2FF"/>
+            <a:srgbClr val="1E2761"/>
           </a:solidFill>
           <a:ln>
             <a:noFill/>
@@ -5456,23 +6241,32 @@
           </a:fontRef>
         </p:style>
         <p:txBody>
-          <a:bodyPr rtlCol="0" anchor="ctr"/>
+          <a:bodyPr rtlCol="0" anchor="ctr" wrap="square"/>
           <a:lstStyle/>
           <a:p>
             <a:pPr algn="ctr"/>
-          </a:p>
-        </p:txBody>
-      </p:sp>
-      <p:sp>
-        <p:nvSpPr>
-          <p:cNvPr id="9" name="TextBox 8"/>
+            <a:r>
+              <a:rPr sz="2200" b="1">
+                <a:solidFill>
+                  <a:srgbClr val="FFFFFF"/>
+                </a:solidFill>
+                <a:latin typeface="Calibri"/>
+              </a:rPr>
+              <a:t>Detect</a:t>
+            </a:r>
+          </a:p>
+        </p:txBody>
+      </p:sp>
+      <p:sp>
+        <p:nvSpPr>
+          <p:cNvPr id="8" name="TextBox 7"/>
           <p:cNvSpPr txBox="1"/>
           <p:nvPr/>
         </p:nvSpPr>
         <p:spPr>
           <a:xfrm>
-            <a:off x="6812280" y="7589520"/>
-            <a:ext cx="4663440" cy="1737360"/>
+            <a:off x="3200400" y="4480559"/>
+            <a:ext cx="2880360" cy="914400"/>
           </a:xfrm>
           <a:prstGeom prst="rect">
             <a:avLst/>
@@ -5485,50 +6279,39 @@
           </a:bodyPr>
           <a:lstStyle/>
           <a:p>
-            <a:r>
-              <a:rPr sz="2200" b="1">
+            <a:pPr algn="ctr">
+              <a:spcAft>
+                <a:spcPts val="600"/>
+              </a:spcAft>
+            </a:pPr>
+            <a:r>
+              <a:rPr sz="1600" b="0">
                 <a:solidFill>
-                  <a:srgbClr val="1E2761"/>
+                  <a:srgbClr val="5A5A5A"/>
                 </a:solidFill>
                 <a:latin typeface="Calibri"/>
               </a:rPr>
-              <a:t>Quality Gate</a:t>
-            </a:r>
-          </a:p>
-          <a:p>
-            <a:pPr>
-              <a:spcBef>
-                <a:spcPts val="800"/>
-              </a:spcBef>
-            </a:pPr>
-            <a:r>
-              <a:rPr sz="1900">
-                <a:solidFill>
-                  <a:srgbClr val="111111"/>
-                </a:solidFill>
-                <a:latin typeface="Calibri"/>
-              </a:rPr>
-              <a:t>Only sharp frontal faces enroll. No junk matches.</a:t>
-            </a:r>
-          </a:p>
-        </p:txBody>
-      </p:sp>
-      <p:sp>
-        <p:nvSpPr>
-          <p:cNvPr id="10" name="Rounded Rectangle 9"/>
+              <a:t>YOLOv8, 720p</a:t>
+            </a:r>
+          </a:p>
+        </p:txBody>
+      </p:sp>
+      <p:sp>
+        <p:nvSpPr>
+          <p:cNvPr id="9" name="Chevron 8"/>
           <p:cNvSpPr/>
           <p:nvPr/>
         </p:nvSpPr>
         <p:spPr>
           <a:xfrm>
-            <a:off x="12161520" y="7315200"/>
-            <a:ext cx="5212080" cy="2286000"/>
-          </a:xfrm>
-          <a:prstGeom prst="roundRect">
+            <a:off x="5669279" y="2834640"/>
+            <a:ext cx="2880360" cy="1554480"/>
+          </a:xfrm>
+          <a:prstGeom prst="chevron">
             <a:avLst/>
           </a:prstGeom>
           <a:solidFill>
-            <a:srgbClr val="EEF2FF"/>
+            <a:srgbClr val="1E2761"/>
           </a:solidFill>
           <a:ln>
             <a:noFill/>
@@ -5549,23 +6332,32 @@
           </a:fontRef>
         </p:style>
         <p:txBody>
-          <a:bodyPr rtlCol="0" anchor="ctr"/>
+          <a:bodyPr rtlCol="0" anchor="ctr" wrap="square"/>
           <a:lstStyle/>
           <a:p>
             <a:pPr algn="ctr"/>
-          </a:p>
-        </p:txBody>
-      </p:sp>
-      <p:sp>
-        <p:nvSpPr>
-          <p:cNvPr id="11" name="TextBox 10"/>
+            <a:r>
+              <a:rPr sz="2200" b="1">
+                <a:solidFill>
+                  <a:srgbClr val="FFFFFF"/>
+                </a:solidFill>
+                <a:latin typeface="Calibri"/>
+              </a:rPr>
+              <a:t>Track</a:t>
+            </a:r>
+          </a:p>
+        </p:txBody>
+      </p:sp>
+      <p:sp>
+        <p:nvSpPr>
+          <p:cNvPr id="10" name="TextBox 9"/>
           <p:cNvSpPr txBox="1"/>
           <p:nvPr/>
         </p:nvSpPr>
         <p:spPr>
           <a:xfrm>
-            <a:off x="12435840" y="7589520"/>
-            <a:ext cx="4663440" cy="1737360"/>
+            <a:off x="5669279" y="4480559"/>
+            <a:ext cx="2880360" cy="914400"/>
           </a:xfrm>
           <a:prstGeom prst="rect">
             <a:avLst/>
@@ -5578,6 +6370,347 @@
           </a:bodyPr>
           <a:lstStyle/>
           <a:p>
+            <a:pPr algn="ctr">
+              <a:spcAft>
+                <a:spcPts val="600"/>
+              </a:spcAft>
+            </a:pPr>
+            <a:r>
+              <a:rPr sz="1600" b="0">
+                <a:solidFill>
+                  <a:srgbClr val="5A5A5A"/>
+                </a:solidFill>
+                <a:latin typeface="Calibri"/>
+              </a:rPr>
+              <a:t>ByteTrack IDs</a:t>
+            </a:r>
+          </a:p>
+        </p:txBody>
+      </p:sp>
+      <p:sp>
+        <p:nvSpPr>
+          <p:cNvPr id="11" name="Chevron 10"/>
+          <p:cNvSpPr/>
+          <p:nvPr/>
+        </p:nvSpPr>
+        <p:spPr>
+          <a:xfrm>
+            <a:off x="8138160" y="2834640"/>
+            <a:ext cx="2880360" cy="1554480"/>
+          </a:xfrm>
+          <a:prstGeom prst="chevron">
+            <a:avLst/>
+          </a:prstGeom>
+          <a:solidFill>
+            <a:srgbClr val="1E2761"/>
+          </a:solidFill>
+          <a:ln>
+            <a:noFill/>
+          </a:ln>
+        </p:spPr>
+        <p:style>
+          <a:lnRef idx="1">
+            <a:schemeClr val="accent1"/>
+          </a:lnRef>
+          <a:fillRef idx="3">
+            <a:schemeClr val="accent1"/>
+          </a:fillRef>
+          <a:effectRef idx="2">
+            <a:schemeClr val="accent1"/>
+          </a:effectRef>
+          <a:fontRef idx="minor">
+            <a:schemeClr val="lt1"/>
+          </a:fontRef>
+        </p:style>
+        <p:txBody>
+          <a:bodyPr rtlCol="0" anchor="ctr" wrap="square"/>
+          <a:lstStyle/>
+          <a:p>
+            <a:pPr algn="ctr"/>
+            <a:r>
+              <a:rPr sz="2200" b="1">
+                <a:solidFill>
+                  <a:srgbClr val="FFFFFF"/>
+                </a:solidFill>
+                <a:latin typeface="Calibri"/>
+              </a:rPr>
+              <a:t>Face</a:t>
+            </a:r>
+          </a:p>
+        </p:txBody>
+      </p:sp>
+      <p:sp>
+        <p:nvSpPr>
+          <p:cNvPr id="12" name="TextBox 11"/>
+          <p:cNvSpPr txBox="1"/>
+          <p:nvPr/>
+        </p:nvSpPr>
+        <p:spPr>
+          <a:xfrm>
+            <a:off x="8138160" y="4480559"/>
+            <a:ext cx="2880360" cy="914400"/>
+          </a:xfrm>
+          <a:prstGeom prst="rect">
+            <a:avLst/>
+          </a:prstGeom>
+          <a:noFill/>
+        </p:spPr>
+        <p:txBody>
+          <a:bodyPr wrap="square">
+            <a:spAutoFit/>
+          </a:bodyPr>
+          <a:lstStyle/>
+          <a:p>
+            <a:pPr algn="ctr">
+              <a:spcAft>
+                <a:spcPts val="600"/>
+              </a:spcAft>
+            </a:pPr>
+            <a:r>
+              <a:rPr sz="1600" b="0">
+                <a:solidFill>
+                  <a:srgbClr val="5A5A5A"/>
+                </a:solidFill>
+                <a:latin typeface="Calibri"/>
+              </a:rPr>
+              <a:t>ArcFace 512-D</a:t>
+            </a:r>
+          </a:p>
+        </p:txBody>
+      </p:sp>
+      <p:sp>
+        <p:nvSpPr>
+          <p:cNvPr id="13" name="Chevron 12"/>
+          <p:cNvSpPr/>
+          <p:nvPr/>
+        </p:nvSpPr>
+        <p:spPr>
+          <a:xfrm>
+            <a:off x="10607040" y="2834640"/>
+            <a:ext cx="2880360" cy="1554480"/>
+          </a:xfrm>
+          <a:prstGeom prst="chevron">
+            <a:avLst/>
+          </a:prstGeom>
+          <a:solidFill>
+            <a:srgbClr val="1E2761"/>
+          </a:solidFill>
+          <a:ln>
+            <a:noFill/>
+          </a:ln>
+        </p:spPr>
+        <p:style>
+          <a:lnRef idx="1">
+            <a:schemeClr val="accent1"/>
+          </a:lnRef>
+          <a:fillRef idx="3">
+            <a:schemeClr val="accent1"/>
+          </a:fillRef>
+          <a:effectRef idx="2">
+            <a:schemeClr val="accent1"/>
+          </a:effectRef>
+          <a:fontRef idx="minor">
+            <a:schemeClr val="lt1"/>
+          </a:fontRef>
+        </p:style>
+        <p:txBody>
+          <a:bodyPr rtlCol="0" anchor="ctr" wrap="square"/>
+          <a:lstStyle/>
+          <a:p>
+            <a:pPr algn="ctr"/>
+            <a:r>
+              <a:rPr sz="2200" b="1">
+                <a:solidFill>
+                  <a:srgbClr val="FFFFFF"/>
+                </a:solidFill>
+                <a:latin typeface="Calibri"/>
+              </a:rPr>
+              <a:t>Match</a:t>
+            </a:r>
+          </a:p>
+        </p:txBody>
+      </p:sp>
+      <p:sp>
+        <p:nvSpPr>
+          <p:cNvPr id="14" name="TextBox 13"/>
+          <p:cNvSpPr txBox="1"/>
+          <p:nvPr/>
+        </p:nvSpPr>
+        <p:spPr>
+          <a:xfrm>
+            <a:off x="10607040" y="4480559"/>
+            <a:ext cx="2880360" cy="914400"/>
+          </a:xfrm>
+          <a:prstGeom prst="rect">
+            <a:avLst/>
+          </a:prstGeom>
+          <a:noFill/>
+        </p:spPr>
+        <p:txBody>
+          <a:bodyPr wrap="square">
+            <a:spAutoFit/>
+          </a:bodyPr>
+          <a:lstStyle/>
+          <a:p>
+            <a:pPr algn="ctr">
+              <a:spcAft>
+                <a:spcPts val="600"/>
+              </a:spcAft>
+            </a:pPr>
+            <a:r>
+              <a:rPr sz="1600" b="0">
+                <a:solidFill>
+                  <a:srgbClr val="5A5A5A"/>
+                </a:solidFill>
+                <a:latin typeface="Calibri"/>
+              </a:rPr>
+              <a:t>Faiss gallery</a:t>
+            </a:r>
+          </a:p>
+        </p:txBody>
+      </p:sp>
+      <p:sp>
+        <p:nvSpPr>
+          <p:cNvPr id="15" name="Chevron 14"/>
+          <p:cNvSpPr/>
+          <p:nvPr/>
+        </p:nvSpPr>
+        <p:spPr>
+          <a:xfrm>
+            <a:off x="13075919" y="2834640"/>
+            <a:ext cx="2880360" cy="1554480"/>
+          </a:xfrm>
+          <a:prstGeom prst="chevron">
+            <a:avLst/>
+          </a:prstGeom>
+          <a:solidFill>
+            <a:srgbClr val="D9A441"/>
+          </a:solidFill>
+          <a:ln>
+            <a:noFill/>
+          </a:ln>
+        </p:spPr>
+        <p:style>
+          <a:lnRef idx="1">
+            <a:schemeClr val="accent1"/>
+          </a:lnRef>
+          <a:fillRef idx="3">
+            <a:schemeClr val="accent1"/>
+          </a:fillRef>
+          <a:effectRef idx="2">
+            <a:schemeClr val="accent1"/>
+          </a:effectRef>
+          <a:fontRef idx="minor">
+            <a:schemeClr val="lt1"/>
+          </a:fontRef>
+        </p:style>
+        <p:txBody>
+          <a:bodyPr rtlCol="0" anchor="ctr" wrap="square"/>
+          <a:lstStyle/>
+          <a:p>
+            <a:pPr algn="ctr"/>
+            <a:r>
+              <a:rPr sz="2200" b="1">
+                <a:solidFill>
+                  <a:srgbClr val="111111"/>
+                </a:solidFill>
+                <a:latin typeface="Calibri"/>
+              </a:rPr>
+              <a:t>Act</a:t>
+            </a:r>
+          </a:p>
+        </p:txBody>
+      </p:sp>
+      <p:sp>
+        <p:nvSpPr>
+          <p:cNvPr id="16" name="TextBox 15"/>
+          <p:cNvSpPr txBox="1"/>
+          <p:nvPr/>
+        </p:nvSpPr>
+        <p:spPr>
+          <a:xfrm>
+            <a:off x="13075919" y="4480559"/>
+            <a:ext cx="2880360" cy="914400"/>
+          </a:xfrm>
+          <a:prstGeom prst="rect">
+            <a:avLst/>
+          </a:prstGeom>
+          <a:noFill/>
+        </p:spPr>
+        <p:txBody>
+          <a:bodyPr wrap="square">
+            <a:spAutoFit/>
+          </a:bodyPr>
+          <a:lstStyle/>
+          <a:p>
+            <a:pPr algn="ctr">
+              <a:spcAft>
+                <a:spcPts val="600"/>
+              </a:spcAft>
+            </a:pPr>
+            <a:r>
+              <a:rPr sz="1600" b="0">
+                <a:solidFill>
+                  <a:srgbClr val="5A5A5A"/>
+                </a:solidFill>
+                <a:latin typeface="Calibri"/>
+              </a:rPr>
+              <a:t>Risk, alert, push</a:t>
+            </a:r>
+          </a:p>
+        </p:txBody>
+      </p:sp>
+      <p:pic>
+        <p:nvPicPr>
+          <p:cNvPr id="17" name="Picture 16" descr="station_concourse.webm_0.jpg"/>
+          <p:cNvPicPr>
+            <a:picLocks noChangeAspect="1"/>
+          </p:cNvPicPr>
+          <p:nvPr/>
+        </p:nvPicPr>
+        <p:blipFill>
+          <a:blip r:embed="rId3"/>
+          <a:stretch>
+            <a:fillRect/>
+          </a:stretch>
+        </p:blipFill>
+        <p:spPr>
+          <a:xfrm>
+            <a:off x="731520" y="5943600"/>
+            <a:ext cx="8229600" cy="3566160"/>
+          </a:xfrm>
+          <a:prstGeom prst="rect">
+            <a:avLst/>
+          </a:prstGeom>
+        </p:spPr>
+      </p:pic>
+      <p:sp>
+        <p:nvSpPr>
+          <p:cNvPr id="18" name="TextBox 17"/>
+          <p:cNvSpPr txBox="1"/>
+          <p:nvPr/>
+        </p:nvSpPr>
+        <p:spPr>
+          <a:xfrm>
+            <a:off x="9509760" y="5943600"/>
+            <a:ext cx="8046720" cy="3566160"/>
+          </a:xfrm>
+          <a:prstGeom prst="rect">
+            <a:avLst/>
+          </a:prstGeom>
+          <a:noFill/>
+        </p:spPr>
+        <p:txBody>
+          <a:bodyPr wrap="square">
+            <a:spAutoFit/>
+          </a:bodyPr>
+          <a:lstStyle/>
+          <a:p>
+            <a:pPr algn="l">
+              <a:spcAft>
+                <a:spcPts val="800"/>
+              </a:spcAft>
+            </a:pPr>
             <a:r>
               <a:rPr sz="2200" b="1">
                 <a:solidFill>
@@ -5585,23 +6718,55 @@
                 </a:solidFill>
                 <a:latin typeface="Calibri"/>
               </a:rPr>
-              <a:t>Demo</a:t>
-            </a:r>
-          </a:p>
-          <a:p>
-            <a:pPr>
-              <a:spcBef>
+              <a:t>Quality gate</a:t>
+            </a:r>
+          </a:p>
+          <a:p>
+            <a:pPr algn="l">
+              <a:spcAft>
                 <a:spcPts val="800"/>
-              </a:spcBef>
+              </a:spcAft>
             </a:pPr>
             <a:r>
-              <a:rPr sz="1900">
+              <a:rPr sz="1900" b="0">
                 <a:solidFill>
                   <a:srgbClr val="111111"/>
                 </a:solidFill>
                 <a:latin typeface="Calibri"/>
               </a:rPr>
-              <a:t>CAM-03: 42 persons, A-1047 at 0.91, Zone C RED, Exit 2</a:t>
+              <a:t>Only sharp frontal faces enroll. No junk matches.</a:t>
+            </a:r>
+          </a:p>
+          <a:p>
+            <a:pPr algn="l">
+              <a:spcAft>
+                <a:spcPts val="800"/>
+              </a:spcAft>
+            </a:pPr>
+            <a:r>
+              <a:rPr sz="2200" b="1">
+                <a:solidFill>
+                  <a:srgbClr val="1E2761"/>
+                </a:solidFill>
+                <a:latin typeface="Calibri"/>
+              </a:rPr>
+              <a:t>Measured</a:t>
+            </a:r>
+          </a:p>
+          <a:p>
+            <a:pPr algn="l">
+              <a:spcAft>
+                <a:spcPts val="800"/>
+              </a:spcAft>
+            </a:pPr>
+            <a:r>
+              <a:rPr sz="1900" b="0">
+                <a:solidFill>
+                  <a:srgbClr val="111111"/>
+                </a:solidFill>
+                <a:latin typeface="Calibri"/>
+              </a:rPr>
+              <a:t>Peak 18 tracked at once, 850 IDs over 2 min of concourse.</a:t>
             </a:r>
           </a:p>
         </p:txBody>
@@ -5742,16 +6907,34 @@
           </a:p>
         </p:txBody>
       </p:sp>
-      <p:sp>
-        <p:nvSpPr>
-          <p:cNvPr id="5" name="TextBox 4"/>
+      <p:graphicFrame>
+        <p:nvGraphicFramePr>
+          <p:cNvPr id="5" name="Chart 4"/>
+          <p:cNvGraphicFramePr>
+            <a:graphicFrameLocks noGrp="1"/>
+          </p:cNvGraphicFramePr>
+          <p:nvPr/>
+        </p:nvGraphicFramePr>
+        <p:xfrm>
+          <a:off x="731520" y="2743200"/>
+          <a:ext cx="8046720" cy="4937760"/>
+        </p:xfrm>
+        <a:graphic>
+          <a:graphicData uri="http://schemas.openxmlformats.org/drawingml/2006/chart">
+            <c:chart xmlns:c="http://schemas.openxmlformats.org/drawingml/2006/chart" r:id="rId3"/>
+          </a:graphicData>
+        </a:graphic>
+      </p:graphicFrame>
+      <p:sp>
+        <p:nvSpPr>
+          <p:cNvPr id="6" name="TextBox 5"/>
           <p:cNvSpPr txBox="1"/>
           <p:nvPr/>
         </p:nvSpPr>
         <p:spPr>
           <a:xfrm>
-            <a:off x="914400" y="2926080"/>
-            <a:ext cx="16459200" cy="4389120"/>
+            <a:off x="9509760" y="2743200"/>
+            <a:ext cx="8046720" cy="2926080"/>
           </a:xfrm>
           <a:prstGeom prst="rect">
             <a:avLst/>
@@ -5765,171 +6948,104 @@
           <a:lstStyle/>
           <a:p>
             <a:pPr algn="l">
-              <a:spcBef>
-                <a:spcPts val="200"/>
-              </a:spcBef>
               <a:spcAft>
-                <a:spcPts val="1000"/>
+                <a:spcPts val="400"/>
               </a:spcAft>
             </a:pPr>
             <a:r>
-              <a:rPr sz="2400" b="1">
+              <a:rPr sz="5400" b="1">
                 <a:solidFill>
                   <a:srgbClr val="1E2761"/>
                 </a:solidFill>
                 <a:latin typeface="Calibri"/>
               </a:rPr>
-              <a:t>• Tracking measured: </a:t>
-            </a:r>
-            <a:r>
-              <a:rPr sz="2400" b="0">
+              <a:t>61 ms</a:t>
+            </a:r>
+          </a:p>
+          <a:p>
+            <a:pPr algn="l">
+              <a:spcAft>
+                <a:spcPts val="400"/>
+              </a:spcAft>
+            </a:pPr>
+            <a:r>
+              <a:rPr sz="1800" b="0">
                 <a:solidFill>
-                  <a:srgbClr val="111111"/>
+                  <a:srgbClr val="5A5A5A"/>
                 </a:solidFill>
                 <a:latin typeface="Calibri"/>
               </a:rPr>
-              <a:t>YOLOv8s plus ByteTrack 15 to 30 FPS on RTX 4050, 8 with full overlay. Assoc under 1ms.</a:t>
+              <a:t>face match on GPU, was 438 ms on CPU</a:t>
             </a:r>
           </a:p>
           <a:p>
             <a:pPr algn="l">
-              <a:spcBef>
-                <a:spcPts val="200"/>
-              </a:spcBef>
               <a:spcAft>
-                <a:spcPts val="1000"/>
+                <a:spcPts val="400"/>
               </a:spcAft>
             </a:pPr>
             <a:r>
-              <a:rPr sz="2400" b="1">
+              <a:rPr sz="5400" b="1">
                 <a:solidFill>
                   <a:srgbClr val="1E2761"/>
                 </a:solidFill>
                 <a:latin typeface="Calibri"/>
               </a:rPr>
-              <a:t>• Face measured: </a:t>
-            </a:r>
-            <a:r>
-              <a:rPr sz="2400" b="0">
+              <a:t>1.2+</a:t>
+            </a:r>
+          </a:p>
+          <a:p>
+            <a:pPr algn="l">
+              <a:spcAft>
+                <a:spcPts val="400"/>
+              </a:spcAft>
+            </a:pPr>
+            <a:r>
+              <a:rPr sz="1800" b="0">
                 <a:solidFill>
-                  <a:srgbClr val="111111"/>
+                  <a:srgbClr val="5A5A5A"/>
                 </a:solidFill>
                 <a:latin typeface="Calibri"/>
               </a:rPr>
-              <a:t>buffalo_s 61ms steady on GPU, was 438ms on CPU. Faiss gallery instant under 50k IDs.</a:t>
-            </a:r>
-          </a:p>
-          <a:p>
-            <a:pPr algn="l">
-              <a:spcBef>
-                <a:spcPts val="200"/>
-              </a:spcBef>
-              <a:spcAft>
-                <a:spcPts val="1000"/>
-              </a:spcAft>
-            </a:pPr>
-            <a:r>
-              <a:rPr sz="2400" b="1">
-                <a:solidFill>
-                  <a:srgbClr val="1E2761"/>
-                </a:solidFill>
-                <a:latin typeface="Calibri"/>
-              </a:rPr>
-              <a:t>• Stampede warning: </a:t>
-            </a:r>
-            <a:r>
-              <a:rPr sz="2400" b="0">
-                <a:solidFill>
-                  <a:srgbClr val="111111"/>
-                </a:solidFill>
-                <a:latin typeface="Calibri"/>
-              </a:rPr>
-              <a:t>AURORA 94.3 percent, 13.8s early lead. Our rule meter fired RED 1.2 plus on dense test.</a:t>
-            </a:r>
-          </a:p>
-          <a:p>
-            <a:pPr algn="l">
-              <a:spcBef>
-                <a:spcPts val="200"/>
-              </a:spcBef>
-              <a:spcAft>
-                <a:spcPts val="1000"/>
-              </a:spcAft>
-            </a:pPr>
-            <a:r>
-              <a:rPr sz="2400" b="1">
-                <a:solidFill>
-                  <a:srgbClr val="1E2761"/>
-                </a:solidFill>
-                <a:latin typeface="Calibri"/>
-              </a:rPr>
-              <a:t>• 24h MVP: </a:t>
-            </a:r>
-            <a:r>
-              <a:rPr sz="2400" b="0">
-                <a:solidFill>
-                  <a:srgbClr val="111111"/>
-                </a:solidFill>
-                <a:latin typeface="Calibri"/>
-              </a:rPr>
-              <a:t>Webcam plus clips plus enrolled faces. No extra hardware needed for demo.</a:t>
-            </a:r>
-          </a:p>
-        </p:txBody>
-      </p:sp>
-      <p:sp>
-        <p:nvSpPr>
-          <p:cNvPr id="6" name="Rounded Rectangle 5"/>
-          <p:cNvSpPr/>
+              <a:t>risk score where RED fired on dense test</a:t>
+            </a:r>
+          </a:p>
+        </p:txBody>
+      </p:sp>
+      <p:pic>
+        <p:nvPicPr>
+          <p:cNvPr id="7" name="Picture 6" descr="station_concourse.webm_1.jpg"/>
+          <p:cNvPicPr>
+            <a:picLocks noChangeAspect="1"/>
+          </p:cNvPicPr>
           <p:nvPr/>
-        </p:nvSpPr>
+        </p:nvPicPr>
+        <p:blipFill>
+          <a:blip r:embed="rId4"/>
+          <a:stretch>
+            <a:fillRect/>
+          </a:stretch>
+        </p:blipFill>
         <p:spPr>
           <a:xfrm>
-            <a:off x="914400" y="7315200"/>
-            <a:ext cx="5212080" cy="2286000"/>
-          </a:xfrm>
-          <a:prstGeom prst="roundRect">
+            <a:off x="9509760" y="6035040"/>
+            <a:ext cx="8046720" cy="2560320"/>
+          </a:xfrm>
+          <a:prstGeom prst="rect">
             <a:avLst/>
           </a:prstGeom>
-          <a:solidFill>
-            <a:srgbClr val="EEF2FF"/>
-          </a:solidFill>
-          <a:ln>
-            <a:noFill/>
-          </a:ln>
         </p:spPr>
-        <p:style>
-          <a:lnRef idx="1">
-            <a:schemeClr val="accent1"/>
-          </a:lnRef>
-          <a:fillRef idx="3">
-            <a:schemeClr val="accent1"/>
-          </a:fillRef>
-          <a:effectRef idx="2">
-            <a:schemeClr val="accent1"/>
-          </a:effectRef>
-          <a:fontRef idx="minor">
-            <a:schemeClr val="lt1"/>
-          </a:fontRef>
-        </p:style>
-        <p:txBody>
-          <a:bodyPr rtlCol="0" anchor="ctr"/>
-          <a:lstStyle/>
-          <a:p>
-            <a:pPr algn="ctr"/>
-          </a:p>
-        </p:txBody>
-      </p:sp>
-      <p:sp>
-        <p:nvSpPr>
-          <p:cNvPr id="7" name="TextBox 6"/>
+      </p:pic>
+      <p:sp>
+        <p:nvSpPr>
+          <p:cNvPr id="8" name="TextBox 7"/>
           <p:cNvSpPr txBox="1"/>
           <p:nvPr/>
         </p:nvSpPr>
         <p:spPr>
           <a:xfrm>
-            <a:off x="1188720" y="7589520"/>
-            <a:ext cx="4663440" cy="1737360"/>
+            <a:off x="731520" y="7955279"/>
+            <a:ext cx="8046720" cy="548640"/>
           </a:xfrm>
           <a:prstGeom prst="rect">
             <a:avLst/>
@@ -5942,216 +7058,19 @@
           </a:bodyPr>
           <a:lstStyle/>
           <a:p>
-            <a:r>
-              <a:rPr sz="2200" b="1">
+            <a:pPr algn="l">
+              <a:spcAft>
+                <a:spcPts val="600"/>
+              </a:spcAft>
+            </a:pPr>
+            <a:r>
+              <a:rPr sz="1500" b="0">
                 <a:solidFill>
-                  <a:srgbClr val="1E2761"/>
+                  <a:srgbClr val="5A5A5A"/>
                 </a:solidFill>
                 <a:latin typeface="Calibri"/>
               </a:rPr>
-              <a:t>Evidence</a:t>
-            </a:r>
-          </a:p>
-          <a:p>
-            <a:pPr>
-              <a:spcBef>
-                <a:spcPts val="800"/>
-              </a:spcBef>
-            </a:pPr>
-            <a:r>
-              <a:rPr sz="1900">
-                <a:solidFill>
-                  <a:srgbClr val="111111"/>
-                </a:solidFill>
-                <a:latin typeface="Calibri"/>
-              </a:rPr>
-              <a:t>2025-26 CPU studies plus InsightFace benchmarks</a:t>
-            </a:r>
-          </a:p>
-        </p:txBody>
-      </p:sp>
-      <p:sp>
-        <p:nvSpPr>
-          <p:cNvPr id="8" name="Rounded Rectangle 7"/>
-          <p:cNvSpPr/>
-          <p:nvPr/>
-        </p:nvSpPr>
-        <p:spPr>
-          <a:xfrm>
-            <a:off x="6537960" y="7315200"/>
-            <a:ext cx="5212080" cy="2286000"/>
-          </a:xfrm>
-          <a:prstGeom prst="roundRect">
-            <a:avLst/>
-          </a:prstGeom>
-          <a:solidFill>
-            <a:srgbClr val="EEF2FF"/>
-          </a:solidFill>
-          <a:ln>
-            <a:noFill/>
-          </a:ln>
-        </p:spPr>
-        <p:style>
-          <a:lnRef idx="1">
-            <a:schemeClr val="accent1"/>
-          </a:lnRef>
-          <a:fillRef idx="3">
-            <a:schemeClr val="accent1"/>
-          </a:fillRef>
-          <a:effectRef idx="2">
-            <a:schemeClr val="accent1"/>
-          </a:effectRef>
-          <a:fontRef idx="minor">
-            <a:schemeClr val="lt1"/>
-          </a:fontRef>
-        </p:style>
-        <p:txBody>
-          <a:bodyPr rtlCol="0" anchor="ctr"/>
-          <a:lstStyle/>
-          <a:p>
-            <a:pPr algn="ctr"/>
-          </a:p>
-        </p:txBody>
-      </p:sp>
-      <p:sp>
-        <p:nvSpPr>
-          <p:cNvPr id="9" name="TextBox 8"/>
-          <p:cNvSpPr txBox="1"/>
-          <p:nvPr/>
-        </p:nvSpPr>
-        <p:spPr>
-          <a:xfrm>
-            <a:off x="6812280" y="7589520"/>
-            <a:ext cx="4663440" cy="1737360"/>
-          </a:xfrm>
-          <a:prstGeom prst="rect">
-            <a:avLst/>
-          </a:prstGeom>
-          <a:noFill/>
-        </p:spPr>
-        <p:txBody>
-          <a:bodyPr wrap="square">
-            <a:spAutoFit/>
-          </a:bodyPr>
-          <a:lstStyle/>
-          <a:p>
-            <a:r>
-              <a:rPr sz="2200" b="1">
-                <a:solidFill>
-                  <a:srgbClr val="1E2761"/>
-                </a:solidFill>
-                <a:latin typeface="Calibri"/>
-              </a:rPr>
-              <a:t>Tuning</a:t>
-            </a:r>
-          </a:p>
-          <a:p>
-            <a:pPr>
-              <a:spcBef>
-                <a:spcPts val="800"/>
-              </a:spcBef>
-            </a:pPr>
-            <a:r>
-              <a:rPr sz="1900">
-                <a:solidFill>
-                  <a:srgbClr val="111111"/>
-                </a:solidFill>
-                <a:latin typeface="Calibri"/>
-              </a:rPr>
-              <a:t>640 input, 720p, skip 2 frames for real-time laptop</a:t>
-            </a:r>
-          </a:p>
-        </p:txBody>
-      </p:sp>
-      <p:sp>
-        <p:nvSpPr>
-          <p:cNvPr id="10" name="Rounded Rectangle 9"/>
-          <p:cNvSpPr/>
-          <p:nvPr/>
-        </p:nvSpPr>
-        <p:spPr>
-          <a:xfrm>
-            <a:off x="12161520" y="7315200"/>
-            <a:ext cx="5212080" cy="2286000"/>
-          </a:xfrm>
-          <a:prstGeom prst="roundRect">
-            <a:avLst/>
-          </a:prstGeom>
-          <a:solidFill>
-            <a:srgbClr val="EEF2FF"/>
-          </a:solidFill>
-          <a:ln>
-            <a:noFill/>
-          </a:ln>
-        </p:spPr>
-        <p:style>
-          <a:lnRef idx="1">
-            <a:schemeClr val="accent1"/>
-          </a:lnRef>
-          <a:fillRef idx="3">
-            <a:schemeClr val="accent1"/>
-          </a:fillRef>
-          <a:effectRef idx="2">
-            <a:schemeClr val="accent1"/>
-          </a:effectRef>
-          <a:fontRef idx="minor">
-            <a:schemeClr val="lt1"/>
-          </a:fontRef>
-        </p:style>
-        <p:txBody>
-          <a:bodyPr rtlCol="0" anchor="ctr"/>
-          <a:lstStyle/>
-          <a:p>
-            <a:pPr algn="ctr"/>
-          </a:p>
-        </p:txBody>
-      </p:sp>
-      <p:sp>
-        <p:nvSpPr>
-          <p:cNvPr id="11" name="TextBox 10"/>
-          <p:cNvSpPr txBox="1"/>
-          <p:nvPr/>
-        </p:nvSpPr>
-        <p:spPr>
-          <a:xfrm>
-            <a:off x="12435840" y="7589520"/>
-            <a:ext cx="4663440" cy="1737360"/>
-          </a:xfrm>
-          <a:prstGeom prst="rect">
-            <a:avLst/>
-          </a:prstGeom>
-          <a:noFill/>
-        </p:spPr>
-        <p:txBody>
-          <a:bodyPr wrap="square">
-            <a:spAutoFit/>
-          </a:bodyPr>
-          <a:lstStyle/>
-          <a:p>
-            <a:r>
-              <a:rPr sz="2200" b="1">
-                <a:solidFill>
-                  <a:srgbClr val="1E2761"/>
-                </a:solidFill>
-                <a:latin typeface="Calibri"/>
-              </a:rPr>
-              <a:t>Fallback</a:t>
-            </a:r>
-          </a:p>
-          <a:p>
-            <a:pPr>
-              <a:spcBef>
-                <a:spcPts val="800"/>
-              </a:spcBef>
-            </a:pPr>
-            <a:r>
-              <a:rPr sz="1900">
-                <a:solidFill>
-                  <a:srgbClr val="111111"/>
-                </a:solidFill>
-                <a:latin typeface="Calibri"/>
-              </a:rPr>
-              <a:t>IoU tracker 64 FPS and clothing search if face hidden</a:t>
+              <a:t>YOLOv8s plus ByteTrack on RTX 4050 laptop. No extra hardware.</a:t>
             </a:r>
           </a:p>
         </p:txBody>
@@ -6292,16 +7211,40 @@
           </a:p>
         </p:txBody>
       </p:sp>
-      <p:sp>
-        <p:nvSpPr>
-          <p:cNvPr id="5" name="TextBox 4"/>
+      <p:pic>
+        <p:nvPicPr>
+          <p:cNvPr id="5" name="Picture 4" descr="temple_best.jpg"/>
+          <p:cNvPicPr>
+            <a:picLocks noChangeAspect="1"/>
+          </p:cNvPicPr>
+          <p:nvPr/>
+        </p:nvPicPr>
+        <p:blipFill>
+          <a:blip r:embed="rId3"/>
+          <a:stretch>
+            <a:fillRect/>
+          </a:stretch>
+        </p:blipFill>
+        <p:spPr>
+          <a:xfrm>
+            <a:off x="731520" y="2560320"/>
+            <a:ext cx="7680960" cy="6400800"/>
+          </a:xfrm>
+          <a:prstGeom prst="rect">
+            <a:avLst/>
+          </a:prstGeom>
+        </p:spPr>
+      </p:pic>
+      <p:sp>
+        <p:nvSpPr>
+          <p:cNvPr id="6" name="TextBox 5"/>
           <p:cNvSpPr txBox="1"/>
           <p:nvPr/>
         </p:nvSpPr>
         <p:spPr>
           <a:xfrm>
-            <a:off x="914400" y="2926080"/>
-            <a:ext cx="16459200" cy="4389120"/>
+            <a:off x="9144000" y="2560320"/>
+            <a:ext cx="8412480" cy="2011680"/>
           </a:xfrm>
           <a:prstGeom prst="rect">
             <a:avLst/>
@@ -6315,128 +7258,48 @@
           <a:lstStyle/>
           <a:p>
             <a:pPr algn="l">
-              <a:spcBef>
-                <a:spcPts val="200"/>
-              </a:spcBef>
               <a:spcAft>
-                <a:spcPts val="1000"/>
+                <a:spcPts val="800"/>
               </a:spcAft>
             </a:pPr>
             <a:r>
-              <a:rPr sz="2600" b="1">
+              <a:rPr sz="2100" b="0">
+                <a:solidFill>
+                  <a:srgbClr val="111111"/>
+                </a:solidFill>
+                <a:latin typeface="Calibri"/>
+              </a:rPr>
+              <a:t>Before: 50 screens, one tired operator.</a:t>
+            </a:r>
+          </a:p>
+          <a:p>
+            <a:pPr algn="l">
+              <a:spcAft>
+                <a:spcPts val="800"/>
+              </a:spcAft>
+            </a:pPr>
+            <a:r>
+              <a:rPr sz="2100" b="1">
                 <a:solidFill>
                   <a:srgbClr val="1E2761"/>
                 </a:solidFill>
                 <a:latin typeface="Calibri"/>
               </a:rPr>
-              <a:t>• Lives saved: </a:t>
-            </a:r>
-            <a:r>
-              <a:rPr sz="2600" b="0">
-                <a:solidFill>
-                  <a:srgbClr val="111111"/>
-                </a:solidFill>
-                <a:latin typeface="Calibri"/>
-              </a:rPr>
-              <a:t>Bottleneck caught 60s before human. Early diversion with PA and signage.</a:t>
-            </a:r>
-          </a:p>
-          <a:p>
-            <a:pPr algn="l">
-              <a:spcBef>
-                <a:spcPts val="200"/>
-              </a:spcBef>
-              <a:spcAft>
-                <a:spcPts val="1000"/>
-              </a:spcAft>
-            </a:pPr>
-            <a:r>
-              <a:rPr sz="2600" b="1">
-                <a:solidFill>
-                  <a:srgbClr val="1E2761"/>
-                </a:solidFill>
-                <a:latin typeface="Calibri"/>
-              </a:rPr>
-              <a:t>• Find fast: </a:t>
-            </a:r>
-            <a:r>
-              <a:rPr sz="2600" b="0">
-                <a:solidFill>
-                  <a:srgbClr val="111111"/>
-                </a:solidFill>
-                <a:latin typeface="Calibri"/>
-              </a:rPr>
-              <a:t>Lost kid or suspect by photo or clothing filter in under 2s with clip export.</a:t>
-            </a:r>
-          </a:p>
-          <a:p>
-            <a:pPr algn="l">
-              <a:spcBef>
-                <a:spcPts val="200"/>
-              </a:spcBef>
-              <a:spcAft>
-                <a:spcPts val="1000"/>
-              </a:spcAft>
-            </a:pPr>
-            <a:r>
-              <a:rPr sz="2600" b="1">
-                <a:solidFill>
-                  <a:srgbClr val="1E2761"/>
-                </a:solidFill>
-                <a:latin typeface="Calibri"/>
-              </a:rPr>
-              <a:t>• Where it fits: </a:t>
-            </a:r>
-            <a:r>
-              <a:rPr sz="2600" b="0">
-                <a:solidFill>
-                  <a:srgbClr val="111111"/>
-                </a:solidFill>
-                <a:latin typeface="Calibri"/>
-              </a:rPr>
-              <a:t>Mela, stadium, station, campus and mall. Same wall, zone-wise push.</a:t>
-            </a:r>
-          </a:p>
-          <a:p>
-            <a:pPr algn="l">
-              <a:spcBef>
-                <a:spcPts val="200"/>
-              </a:spcBef>
-              <a:spcAft>
-                <a:spcPts val="1000"/>
-              </a:spcAft>
-            </a:pPr>
-            <a:r>
-              <a:rPr sz="2600" b="1">
-                <a:solidFill>
-                  <a:srgbClr val="1E2761"/>
-                </a:solidFill>
-                <a:latin typeface="Calibri"/>
-              </a:rPr>
-              <a:t>• Pilot metric: </a:t>
-            </a:r>
-            <a:r>
-              <a:rPr sz="2600" b="0">
-                <a:solidFill>
-                  <a:srgbClr val="111111"/>
-                </a:solidFill>
-                <a:latin typeface="Calibri"/>
-              </a:rPr>
-              <a:t>Over 60s lead time, under 2s search, under 1s alert, audit ready.</a:t>
-            </a:r>
-          </a:p>
-        </p:txBody>
-      </p:sp>
-      <p:sp>
-        <p:nvSpPr>
-          <p:cNvPr id="6" name="Rounded Rectangle 5"/>
+              <a:t>After: one wall, zone-wise push to guards.</a:t>
+            </a:r>
+          </a:p>
+        </p:txBody>
+      </p:sp>
+      <p:sp>
+        <p:nvSpPr>
+          <p:cNvPr id="7" name="Rounded Rectangle 6"/>
           <p:cNvSpPr/>
           <p:nvPr/>
         </p:nvSpPr>
         <p:spPr>
           <a:xfrm>
-            <a:off x="914400" y="7315200"/>
-            <a:ext cx="5212080" cy="2286000"/>
+            <a:off x="9144000" y="4754880"/>
+            <a:ext cx="8412480" cy="1325880"/>
           </a:xfrm>
           <a:prstGeom prst="roundRect">
             <a:avLst/>
@@ -6472,14 +7335,14 @@
       </p:sp>
       <p:sp>
         <p:nvSpPr>
-          <p:cNvPr id="7" name="TextBox 6"/>
+          <p:cNvPr id="8" name="TextBox 7"/>
           <p:cNvSpPr txBox="1"/>
           <p:nvPr/>
         </p:nvSpPr>
         <p:spPr>
           <a:xfrm>
-            <a:off x="1188720" y="7589520"/>
-            <a:ext cx="4663440" cy="1737360"/>
+            <a:off x="9418320" y="4983480"/>
+            <a:ext cx="7863840" cy="868680"/>
           </a:xfrm>
           <a:prstGeom prst="rect">
             <a:avLst/>
@@ -6492,8 +7355,13 @@
           </a:bodyPr>
           <a:lstStyle/>
           <a:p>
-            <a:r>
-              <a:rPr sz="2200" b="1">
+            <a:pPr algn="l">
+              <a:spcAft>
+                <a:spcPts val="600"/>
+              </a:spcAft>
+            </a:pPr>
+            <a:r>
+              <a:rPr sz="2100" b="1">
                 <a:solidFill>
                   <a:srgbClr val="1E2761"/>
                 </a:solidFill>
@@ -6503,33 +7371,33 @@
             </a:r>
           </a:p>
           <a:p>
-            <a:pPr>
-              <a:spcBef>
-                <a:spcPts val="800"/>
-              </a:spcBef>
+            <a:pPr algn="l">
+              <a:spcAft>
+                <a:spcPts val="600"/>
+              </a:spcAft>
             </a:pPr>
             <a:r>
-              <a:rPr sz="1900">
+              <a:rPr sz="1800" b="0">
                 <a:solidFill>
                   <a:srgbClr val="111111"/>
                 </a:solidFill>
                 <a:latin typeface="Calibri"/>
               </a:rPr>
-              <a:t>One screen replaces 50-screen stare</a:t>
-            </a:r>
-          </a:p>
-        </p:txBody>
-      </p:sp>
-      <p:sp>
-        <p:nvSpPr>
-          <p:cNvPr id="8" name="Rounded Rectangle 7"/>
+              <a:t>Bottleneck flagged 60s before humans see it</a:t>
+            </a:r>
+          </a:p>
+        </p:txBody>
+      </p:sp>
+      <p:sp>
+        <p:nvSpPr>
+          <p:cNvPr id="9" name="Rounded Rectangle 8"/>
           <p:cNvSpPr/>
           <p:nvPr/>
         </p:nvSpPr>
         <p:spPr>
           <a:xfrm>
-            <a:off x="6537960" y="7315200"/>
-            <a:ext cx="5212080" cy="2286000"/>
+            <a:off x="9144000" y="6217920"/>
+            <a:ext cx="8412480" cy="1325880"/>
           </a:xfrm>
           <a:prstGeom prst="roundRect">
             <a:avLst/>
@@ -6565,14 +7433,14 @@
       </p:sp>
       <p:sp>
         <p:nvSpPr>
-          <p:cNvPr id="9" name="TextBox 8"/>
+          <p:cNvPr id="10" name="TextBox 9"/>
           <p:cNvSpPr txBox="1"/>
           <p:nvPr/>
         </p:nvSpPr>
         <p:spPr>
           <a:xfrm>
-            <a:off x="6812280" y="7589520"/>
-            <a:ext cx="4663440" cy="1737360"/>
+            <a:off x="9418320" y="6446520"/>
+            <a:ext cx="7863840" cy="868680"/>
           </a:xfrm>
           <a:prstGeom prst="rect">
             <a:avLst/>
@@ -6585,8 +7453,13 @@
           </a:bodyPr>
           <a:lstStyle/>
           <a:p>
-            <a:r>
-              <a:rPr sz="2200" b="1">
+            <a:pPr algn="l">
+              <a:spcAft>
+                <a:spcPts val="600"/>
+              </a:spcAft>
+            </a:pPr>
+            <a:r>
+              <a:rPr sz="2100" b="1">
                 <a:solidFill>
                   <a:srgbClr val="1E2761"/>
                 </a:solidFill>
@@ -6596,33 +7469,33 @@
             </a:r>
           </a:p>
           <a:p>
-            <a:pPr>
-              <a:spcBef>
-                <a:spcPts val="800"/>
-              </a:spcBef>
+            <a:pPr algn="l">
+              <a:spcAft>
+                <a:spcPts val="600"/>
+              </a:spcAft>
             </a:pPr>
             <a:r>
-              <a:rPr sz="1900">
+              <a:rPr sz="1800" b="0">
                 <a:solidFill>
                   <a:srgbClr val="111111"/>
                 </a:solidFill>
                 <a:latin typeface="Calibri"/>
               </a:rPr>
-              <a:t>Dossier plus trail plus audit in one click</a:t>
-            </a:r>
-          </a:p>
-        </p:txBody>
-      </p:sp>
-      <p:sp>
-        <p:nvSpPr>
-          <p:cNvPr id="10" name="Rounded Rectangle 9"/>
+              <a:t>Photo search under 2s, dossier plus trail in one click</a:t>
+            </a:r>
+          </a:p>
+        </p:txBody>
+      </p:sp>
+      <p:sp>
+        <p:nvSpPr>
+          <p:cNvPr id="11" name="Rounded Rectangle 10"/>
           <p:cNvSpPr/>
           <p:nvPr/>
         </p:nvSpPr>
         <p:spPr>
           <a:xfrm>
-            <a:off x="12161520" y="7315200"/>
-            <a:ext cx="5212080" cy="2286000"/>
+            <a:off x="9144000" y="7680960"/>
+            <a:ext cx="8412480" cy="1325880"/>
           </a:xfrm>
           <a:prstGeom prst="roundRect">
             <a:avLst/>
@@ -6658,14 +7531,14 @@
       </p:sp>
       <p:sp>
         <p:nvSpPr>
-          <p:cNvPr id="11" name="TextBox 10"/>
+          <p:cNvPr id="12" name="TextBox 11"/>
           <p:cNvSpPr txBox="1"/>
           <p:nvPr/>
         </p:nvSpPr>
         <p:spPr>
           <a:xfrm>
-            <a:off x="12435840" y="7589520"/>
-            <a:ext cx="4663440" cy="1737360"/>
+            <a:off x="9418320" y="7909560"/>
+            <a:ext cx="7863840" cy="868680"/>
           </a:xfrm>
           <a:prstGeom prst="rect">
             <a:avLst/>
@@ -6678,8 +7551,13 @@
           </a:bodyPr>
           <a:lstStyle/>
           <a:p>
-            <a:r>
-              <a:rPr sz="2200" b="1">
+            <a:pPr algn="l">
+              <a:spcAft>
+                <a:spcPts val="600"/>
+              </a:spcAft>
+            </a:pPr>
+            <a:r>
+              <a:rPr sz="2100" b="1">
                 <a:solidFill>
                   <a:srgbClr val="1E2761"/>
                 </a:solidFill>
@@ -6689,13 +7567,13 @@
             </a:r>
           </a:p>
           <a:p>
-            <a:pPr>
-              <a:spcBef>
-                <a:spcPts val="800"/>
-              </a:spcBef>
+            <a:pPr algn="l">
+              <a:spcAft>
+                <a:spcPts val="600"/>
+              </a:spcAft>
             </a:pPr>
             <a:r>
-              <a:rPr sz="1900">
+              <a:rPr sz="1800" b="0">
                 <a:solidFill>
                   <a:srgbClr val="111111"/>
                 </a:solidFill>
@@ -6850,8 +7728,8 @@
         </p:nvSpPr>
         <p:spPr>
           <a:xfrm>
-            <a:off x="914400" y="2926080"/>
-            <a:ext cx="16459200" cy="4389120"/>
+            <a:off x="914400" y="2651760"/>
+            <a:ext cx="16459200" cy="3108960"/>
           </a:xfrm>
           <a:prstGeom prst="rect">
             <a:avLst/>
@@ -6865,114 +7743,458 @@
           <a:lstStyle/>
           <a:p>
             <a:pPr algn="l">
-              <a:spcBef>
-                <a:spcPts val="200"/>
-              </a:spcBef>
               <a:spcAft>
                 <a:spcPts val="1000"/>
               </a:spcAft>
             </a:pPr>
             <a:r>
-              <a:rPr sz="2300" b="1">
+              <a:rPr sz="2000" b="0">
+                <a:solidFill>
+                  <a:srgbClr val="111111"/>
+                </a:solidFill>
+                <a:latin typeface="Calibri"/>
+              </a:rPr>
+              <a:t>YOLOv8 plus ByteTrack, 2025-26 studies: best speed balance; ByteTrack 14 percent faster than BoT-SORT.</a:t>
+            </a:r>
+          </a:p>
+          <a:p>
+            <a:pPr algn="l">
+              <a:spcAft>
+                <a:spcPts val="1000"/>
+              </a:spcAft>
+            </a:pPr>
+            <a:r>
+              <a:rPr sz="2000" b="0">
+                <a:solidFill>
+                  <a:srgbClr val="111111"/>
+                </a:solidFill>
+                <a:latin typeface="Calibri"/>
+              </a:rPr>
+              <a:t>ArcFace buffalo plus Faiss: 99.5 percent LFW, cosine 0.40, vote smoothing steadies matches.</a:t>
+            </a:r>
+          </a:p>
+          <a:p>
+            <a:pPr algn="l">
+              <a:spcAft>
+                <a:spcPts val="1000"/>
+              </a:spcAft>
+            </a:pPr>
+            <a:r>
+              <a:rPr sz="2000" b="0">
+                <a:solidFill>
+                  <a:srgbClr val="111111"/>
+                </a:solidFill>
+                <a:latin typeface="Calibri"/>
+              </a:rPr>
+              <a:t>Stampede models: AURORA hybrid, FTLE bottlenecks, Delhi pilot cut response 37 percent.</a:t>
+            </a:r>
+          </a:p>
+          <a:p>
+            <a:pPr algn="l">
+              <a:spcAft>
+                <a:spcPts val="1000"/>
+              </a:spcAft>
+            </a:pPr>
+            <a:r>
+              <a:rPr sz="2000" b="0">
+                <a:solidFill>
+                  <a:srgbClr val="111111"/>
+                </a:solidFill>
+                <a:latin typeface="Calibri"/>
+              </a:rPr>
+              <a:t>India context: Hathras, Kumbh, station crushes come from density plus blocked exits.</a:t>
+            </a:r>
+          </a:p>
+        </p:txBody>
+      </p:sp>
+      <p:sp>
+        <p:nvSpPr>
+          <p:cNvPr id="6" name="Rounded Rectangle 5"/>
+          <p:cNvSpPr/>
+          <p:nvPr/>
+        </p:nvSpPr>
+        <p:spPr>
+          <a:xfrm>
+            <a:off x="914400" y="6949440"/>
+            <a:ext cx="4023360" cy="1554480"/>
+          </a:xfrm>
+          <a:prstGeom prst="roundRect">
+            <a:avLst/>
+          </a:prstGeom>
+          <a:solidFill>
+            <a:srgbClr val="EEF2FF"/>
+          </a:solidFill>
+          <a:ln>
+            <a:noFill/>
+          </a:ln>
+        </p:spPr>
+        <p:style>
+          <a:lnRef idx="1">
+            <a:schemeClr val="accent1"/>
+          </a:lnRef>
+          <a:fillRef idx="3">
+            <a:schemeClr val="accent1"/>
+          </a:fillRef>
+          <a:effectRef idx="2">
+            <a:schemeClr val="accent1"/>
+          </a:effectRef>
+          <a:fontRef idx="minor">
+            <a:schemeClr val="lt1"/>
+          </a:fontRef>
+        </p:style>
+        <p:txBody>
+          <a:bodyPr rtlCol="0" anchor="ctr"/>
+          <a:lstStyle/>
+          <a:p>
+            <a:pPr algn="ctr"/>
+          </a:p>
+        </p:txBody>
+      </p:sp>
+      <p:sp>
+        <p:nvSpPr>
+          <p:cNvPr id="7" name="TextBox 6"/>
+          <p:cNvSpPr txBox="1"/>
+          <p:nvPr/>
+        </p:nvSpPr>
+        <p:spPr>
+          <a:xfrm>
+            <a:off x="1188720" y="7178040"/>
+            <a:ext cx="3474720" cy="1097280"/>
+          </a:xfrm>
+          <a:prstGeom prst="rect">
+            <a:avLst/>
+          </a:prstGeom>
+          <a:noFill/>
+        </p:spPr>
+        <p:txBody>
+          <a:bodyPr wrap="square">
+            <a:spAutoFit/>
+          </a:bodyPr>
+          <a:lstStyle/>
+          <a:p>
+            <a:pPr algn="l">
+              <a:spcAft>
+                <a:spcPts val="600"/>
+              </a:spcAft>
+            </a:pPr>
+            <a:r>
+              <a:rPr sz="2100" b="1">
                 <a:solidFill>
                   <a:srgbClr val="1E2761"/>
                 </a:solidFill>
                 <a:latin typeface="Calibri"/>
               </a:rPr>
-              <a:t>• YOLO plus ByteTrack: </a:t>
-            </a:r>
-            <a:r>
-              <a:rPr sz="2300" b="0">
+              <a:t>Blurred storage</a:t>
+            </a:r>
+          </a:p>
+          <a:p>
+            <a:pPr algn="l">
+              <a:spcAft>
+                <a:spcPts val="600"/>
+              </a:spcAft>
+            </a:pPr>
+            <a:r>
+              <a:rPr sz="1800" b="0">
                 <a:solidFill>
                   <a:srgbClr val="111111"/>
                 </a:solidFill>
                 <a:latin typeface="Calibri"/>
               </a:rPr>
-              <a:t>2025-26 studies: YOLOv8n best balance. ByteTrack 14 percent faster than BoT-SORT.</a:t>
-            </a:r>
-          </a:p>
+              <a:t>faces blurred on disk</a:t>
+            </a:r>
+          </a:p>
+        </p:txBody>
+      </p:sp>
+      <p:sp>
+        <p:nvSpPr>
+          <p:cNvPr id="8" name="Rounded Rectangle 7"/>
+          <p:cNvSpPr/>
+          <p:nvPr/>
+        </p:nvSpPr>
+        <p:spPr>
+          <a:xfrm>
+            <a:off x="5257800" y="6949440"/>
+            <a:ext cx="4023360" cy="1554480"/>
+          </a:xfrm>
+          <a:prstGeom prst="roundRect">
+            <a:avLst/>
+          </a:prstGeom>
+          <a:solidFill>
+            <a:srgbClr val="EEF2FF"/>
+          </a:solidFill>
+          <a:ln>
+            <a:noFill/>
+          </a:ln>
+        </p:spPr>
+        <p:style>
+          <a:lnRef idx="1">
+            <a:schemeClr val="accent1"/>
+          </a:lnRef>
+          <a:fillRef idx="3">
+            <a:schemeClr val="accent1"/>
+          </a:fillRef>
+          <a:effectRef idx="2">
+            <a:schemeClr val="accent1"/>
+          </a:effectRef>
+          <a:fontRef idx="minor">
+            <a:schemeClr val="lt1"/>
+          </a:fontRef>
+        </p:style>
+        <p:txBody>
+          <a:bodyPr rtlCol="0" anchor="ctr"/>
+          <a:lstStyle/>
+          <a:p>
+            <a:pPr algn="ctr"/>
+          </a:p>
+        </p:txBody>
+      </p:sp>
+      <p:sp>
+        <p:nvSpPr>
+          <p:cNvPr id="9" name="TextBox 8"/>
+          <p:cNvSpPr txBox="1"/>
+          <p:nvPr/>
+        </p:nvSpPr>
+        <p:spPr>
+          <a:xfrm>
+            <a:off x="5532120" y="7178040"/>
+            <a:ext cx="3474720" cy="1097280"/>
+          </a:xfrm>
+          <a:prstGeom prst="rect">
+            <a:avLst/>
+          </a:prstGeom>
+          <a:noFill/>
+        </p:spPr>
+        <p:txBody>
+          <a:bodyPr wrap="square">
+            <a:spAutoFit/>
+          </a:bodyPr>
+          <a:lstStyle/>
           <a:p>
             <a:pPr algn="l">
-              <a:spcBef>
-                <a:spcPts val="200"/>
-              </a:spcBef>
               <a:spcAft>
-                <a:spcPts val="1000"/>
+                <a:spcPts val="600"/>
               </a:spcAft>
             </a:pPr>
             <a:r>
-              <a:rPr sz="2300" b="1">
+              <a:rPr sz="2100" b="1">
                 <a:solidFill>
                   <a:srgbClr val="1E2761"/>
                 </a:solidFill>
                 <a:latin typeface="Calibri"/>
               </a:rPr>
-              <a:t>• ArcFace plus Faiss: </a:t>
-            </a:r>
-            <a:r>
-              <a:rPr sz="2300" b="0">
+              <a:t>7-day purge</a:t>
+            </a:r>
+          </a:p>
+          <a:p>
+            <a:pPr algn="l">
+              <a:spcAft>
+                <a:spcPts val="600"/>
+              </a:spcAft>
+            </a:pPr>
+            <a:r>
+              <a:rPr sz="1800" b="0">
                 <a:solidFill>
                   <a:srgbClr val="111111"/>
                 </a:solidFill>
                 <a:latin typeface="Calibri"/>
               </a:rPr>
-              <a:t>Buffalo pack 99.5 percent LFW. Cosine 0.40 threshold. Temporal smoothing stabilizes.</a:t>
-            </a:r>
-          </a:p>
+              <a:t>auto delete, no backlog</a:t>
+            </a:r>
+          </a:p>
+        </p:txBody>
+      </p:sp>
+      <p:sp>
+        <p:nvSpPr>
+          <p:cNvPr id="10" name="Rounded Rectangle 9"/>
+          <p:cNvSpPr/>
+          <p:nvPr/>
+        </p:nvSpPr>
+        <p:spPr>
+          <a:xfrm>
+            <a:off x="9601200" y="6949440"/>
+            <a:ext cx="4023360" cy="1554480"/>
+          </a:xfrm>
+          <a:prstGeom prst="roundRect">
+            <a:avLst/>
+          </a:prstGeom>
+          <a:solidFill>
+            <a:srgbClr val="EEF2FF"/>
+          </a:solidFill>
+          <a:ln>
+            <a:noFill/>
+          </a:ln>
+        </p:spPr>
+        <p:style>
+          <a:lnRef idx="1">
+            <a:schemeClr val="accent1"/>
+          </a:lnRef>
+          <a:fillRef idx="3">
+            <a:schemeClr val="accent1"/>
+          </a:fillRef>
+          <a:effectRef idx="2">
+            <a:schemeClr val="accent1"/>
+          </a:effectRef>
+          <a:fontRef idx="minor">
+            <a:schemeClr val="lt1"/>
+          </a:fontRef>
+        </p:style>
+        <p:txBody>
+          <a:bodyPr rtlCol="0" anchor="ctr"/>
+          <a:lstStyle/>
+          <a:p>
+            <a:pPr algn="ctr"/>
+          </a:p>
+        </p:txBody>
+      </p:sp>
+      <p:sp>
+        <p:nvSpPr>
+          <p:cNvPr id="11" name="TextBox 10"/>
+          <p:cNvSpPr txBox="1"/>
+          <p:nvPr/>
+        </p:nvSpPr>
+        <p:spPr>
+          <a:xfrm>
+            <a:off x="9875520" y="7178040"/>
+            <a:ext cx="3474720" cy="1097280"/>
+          </a:xfrm>
+          <a:prstGeom prst="rect">
+            <a:avLst/>
+          </a:prstGeom>
+          <a:noFill/>
+        </p:spPr>
+        <p:txBody>
+          <a:bodyPr wrap="square">
+            <a:spAutoFit/>
+          </a:bodyPr>
+          <a:lstStyle/>
           <a:p>
             <a:pPr algn="l">
-              <a:spcBef>
-                <a:spcPts val="200"/>
-              </a:spcBef>
               <a:spcAft>
-                <a:spcPts val="1000"/>
+                <a:spcPts val="600"/>
               </a:spcAft>
             </a:pPr>
             <a:r>
-              <a:rPr sz="2300" b="1">
+              <a:rPr sz="2100" b="1">
                 <a:solidFill>
                   <a:srgbClr val="1E2761"/>
                 </a:solidFill>
                 <a:latin typeface="Calibri"/>
               </a:rPr>
-              <a:t>• Stampede models: </a:t>
-            </a:r>
-            <a:r>
-              <a:rPr sz="2300" b="0">
+              <a:t>Audit log</a:t>
+            </a:r>
+          </a:p>
+          <a:p>
+            <a:pPr algn="l">
+              <a:spcAft>
+                <a:spcPts val="600"/>
+              </a:spcAft>
+            </a:pPr>
+            <a:r>
+              <a:rPr sz="1800" b="0">
                 <a:solidFill>
                   <a:srgbClr val="111111"/>
                 </a:solidFill>
                 <a:latin typeface="Calibri"/>
               </a:rPr>
-              <a:t>AURORA hybrid plus FTLE bottleneck detection, AVSS 2019. Delhi pilot cut response 37pc.</a:t>
-            </a:r>
-          </a:p>
+              <a:t>hash-chained actions</a:t>
+            </a:r>
+          </a:p>
+        </p:txBody>
+      </p:sp>
+      <p:sp>
+        <p:nvSpPr>
+          <p:cNvPr id="12" name="Rounded Rectangle 11"/>
+          <p:cNvSpPr/>
+          <p:nvPr/>
+        </p:nvSpPr>
+        <p:spPr>
+          <a:xfrm>
+            <a:off x="13944600" y="6949440"/>
+            <a:ext cx="4023360" cy="1554480"/>
+          </a:xfrm>
+          <a:prstGeom prst="roundRect">
+            <a:avLst/>
+          </a:prstGeom>
+          <a:solidFill>
+            <a:srgbClr val="EEF2FF"/>
+          </a:solidFill>
+          <a:ln>
+            <a:noFill/>
+          </a:ln>
+        </p:spPr>
+        <p:style>
+          <a:lnRef idx="1">
+            <a:schemeClr val="accent1"/>
+          </a:lnRef>
+          <a:fillRef idx="3">
+            <a:schemeClr val="accent1"/>
+          </a:fillRef>
+          <a:effectRef idx="2">
+            <a:schemeClr val="accent1"/>
+          </a:effectRef>
+          <a:fontRef idx="minor">
+            <a:schemeClr val="lt1"/>
+          </a:fontRef>
+        </p:style>
+        <p:txBody>
+          <a:bodyPr rtlCol="0" anchor="ctr"/>
+          <a:lstStyle/>
+          <a:p>
+            <a:pPr algn="ctr"/>
+          </a:p>
+        </p:txBody>
+      </p:sp>
+      <p:sp>
+        <p:nvSpPr>
+          <p:cNvPr id="13" name="TextBox 12"/>
+          <p:cNvSpPr txBox="1"/>
+          <p:nvPr/>
+        </p:nvSpPr>
+        <p:spPr>
+          <a:xfrm>
+            <a:off x="14218920" y="7178040"/>
+            <a:ext cx="3474720" cy="1097280"/>
+          </a:xfrm>
+          <a:prstGeom prst="rect">
+            <a:avLst/>
+          </a:prstGeom>
+          <a:noFill/>
+        </p:spPr>
+        <p:txBody>
+          <a:bodyPr wrap="square">
+            <a:spAutoFit/>
+          </a:bodyPr>
+          <a:lstStyle/>
           <a:p>
             <a:pPr algn="l">
-              <a:spcBef>
-                <a:spcPts val="200"/>
-              </a:spcBef>
               <a:spcAft>
-                <a:spcPts val="1000"/>
+                <a:spcPts val="600"/>
               </a:spcAft>
             </a:pPr>
             <a:r>
-              <a:rPr sz="2300" b="1">
+              <a:rPr sz="2100" b="1">
                 <a:solidFill>
                   <a:srgbClr val="1E2761"/>
                 </a:solidFill>
                 <a:latin typeface="Calibri"/>
               </a:rPr>
-              <a:t>• India context: </a:t>
-            </a:r>
-            <a:r>
-              <a:rPr sz="2300" b="0">
+              <a:t>No ID linkage</a:t>
+            </a:r>
+          </a:p>
+          <a:p>
+            <a:pPr algn="l">
+              <a:spcAft>
+                <a:spcPts val="600"/>
+              </a:spcAft>
+            </a:pPr>
+            <a:r>
+              <a:rPr sz="1800" b="0">
                 <a:solidFill>
                   <a:srgbClr val="111111"/>
                 </a:solidFill>
                 <a:latin typeface="Calibri"/>
               </a:rPr>
-              <a:t>Hathras, Kumbh and station pattern: density plus blocked exit. STAR-Crowd Kumbh data.</a:t>
+              <a:t>opt-in gallery only</a:t>
             </a:r>
           </a:p>
         </p:txBody>
@@ -7266,4 +8488,324 @@
   <a:objectDefaults/>
   <a:extraClrSchemeLst/>
 </a:theme>
+</file>
+
+<file path=ppt/theme/theme2.xml><?xml version="1.0" encoding="utf-8"?>
+<a:theme xmlns:a="http://schemas.openxmlformats.org/drawingml/2006/main" name="Office Theme">
+  <a:themeElements>
+    <a:clrScheme name="Office">
+      <a:dk1>
+        <a:sysClr val="windowText" lastClr="000000"/>
+      </a:dk1>
+      <a:lt1>
+        <a:sysClr val="window" lastClr="FFFFFF"/>
+      </a:lt1>
+      <a:dk2>
+        <a:srgbClr val="1F497D"/>
+      </a:dk2>
+      <a:lt2>
+        <a:srgbClr val="EEECE1"/>
+      </a:lt2>
+      <a:accent1>
+        <a:srgbClr val="4F81BD"/>
+      </a:accent1>
+      <a:accent2>
+        <a:srgbClr val="C0504D"/>
+      </a:accent2>
+      <a:accent3>
+        <a:srgbClr val="9BBB59"/>
+      </a:accent3>
+      <a:accent4>
+        <a:srgbClr val="8064A2"/>
+      </a:accent4>
+      <a:accent5>
+        <a:srgbClr val="4BACC6"/>
+      </a:accent5>
+      <a:accent6>
+        <a:srgbClr val="F79646"/>
+      </a:accent6>
+      <a:hlink>
+        <a:srgbClr val="0000FF"/>
+      </a:hlink>
+      <a:folHlink>
+        <a:srgbClr val="800080"/>
+      </a:folHlink>
+    </a:clrScheme>
+    <a:fontScheme name="Office">
+      <a:majorFont>
+        <a:latin typeface="Calibri"/>
+        <a:ea typeface=""/>
+        <a:cs typeface=""/>
+        <a:font script="Jpan" typeface="ＭＳ Ｐゴシック"/>
+        <a:font script="Hang" typeface="맑은 고딕"/>
+        <a:font script="Hans" typeface="宋体"/>
+        <a:font script="Hant" typeface="新細明體"/>
+        <a:font script="Arab" typeface="Times New Roman"/>
+        <a:font script="Hebr" typeface="Times New Roman"/>
+        <a:font script="Thai" typeface="Angsana New"/>
+        <a:font script="Ethi" typeface="Nyala"/>
+        <a:font script="Beng" typeface="Vrinda"/>
+        <a:font script="Gujr" typeface="Shruti"/>
+        <a:font script="Khmr" typeface="MoolBoran"/>
+        <a:font script="Knda" typeface="Tunga"/>
+        <a:font script="Guru" typeface="Raavi"/>
+        <a:font script="Cans" typeface="Euphemia"/>
+        <a:font script="Cher" typeface="Plantagenet Cherokee"/>
+        <a:font script="Yiii" typeface="Microsoft Yi Baiti"/>
+        <a:font script="Tibt" typeface="Microsoft Himalaya"/>
+        <a:font script="Thaa" typeface="MV Boli"/>
+        <a:font script="Deva" typeface="Mangal"/>
+        <a:font script="Telu" typeface="Gautami"/>
+        <a:font script="Taml" typeface="Latha"/>
+        <a:font script="Syrc" typeface="Estrangelo Edessa"/>
+        <a:font script="Orya" typeface="Kalinga"/>
+        <a:font script="Mlym" typeface="Kartika"/>
+        <a:font script="Laoo" typeface="DokChampa"/>
+        <a:font script="Sinh" typeface="Iskoola Pota"/>
+        <a:font script="Mong" typeface="Mongolian Baiti"/>
+        <a:font script="Viet" typeface="Times New Roman"/>
+        <a:font script="Uigh" typeface="Microsoft Uighur"/>
+        <a:font script="Geor" typeface="Sylfaen"/>
+      </a:majorFont>
+      <a:minorFont>
+        <a:latin typeface="Calibri"/>
+        <a:ea typeface=""/>
+        <a:cs typeface=""/>
+        <a:font script="Jpan" typeface="ＭＳ Ｐゴシック"/>
+        <a:font script="Hang" typeface="맑은 고딕"/>
+        <a:font script="Hans" typeface="宋体"/>
+        <a:font script="Hant" typeface="新細明體"/>
+        <a:font script="Arab" typeface="Arial"/>
+        <a:font script="Hebr" typeface="Arial"/>
+        <a:font script="Thai" typeface="Cordia New"/>
+        <a:font script="Ethi" typeface="Nyala"/>
+        <a:font script="Beng" typeface="Vrinda"/>
+        <a:font script="Gujr" typeface="Shruti"/>
+        <a:font script="Khmr" typeface="DaunPenh"/>
+        <a:font script="Knda" typeface="Tunga"/>
+        <a:font script="Guru" typeface="Raavi"/>
+        <a:font script="Cans" typeface="Euphemia"/>
+        <a:font script="Cher" typeface="Plantagenet Cherokee"/>
+        <a:font script="Yiii" typeface="Microsoft Yi Baiti"/>
+        <a:font script="Tibt" typeface="Microsoft Himalaya"/>
+        <a:font script="Thaa" typeface="MV Boli"/>
+        <a:font script="Deva" typeface="Mangal"/>
+        <a:font script="Telu" typeface="Gautami"/>
+        <a:font script="Taml" typeface="Latha"/>
+        <a:font script="Syrc" typeface="Estrangelo Edessa"/>
+        <a:font script="Orya" typeface="Kalinga"/>
+        <a:font script="Mlym" typeface="Kartika"/>
+        <a:font script="Laoo" typeface="DokChampa"/>
+        <a:font script="Sinh" typeface="Iskoola Pota"/>
+        <a:font script="Mong" typeface="Mongolian Baiti"/>
+        <a:font script="Viet" typeface="Arial"/>
+        <a:font script="Uigh" typeface="Microsoft Uighur"/>
+        <a:font script="Geor" typeface="Sylfaen"/>
+      </a:minorFont>
+    </a:fontScheme>
+    <a:fmtScheme name="Office">
+      <a:fillStyleLst>
+        <a:solidFill>
+          <a:schemeClr val="phClr"/>
+        </a:solidFill>
+        <a:gradFill rotWithShape="1">
+          <a:gsLst>
+            <a:gs pos="0">
+              <a:schemeClr val="phClr">
+                <a:tint val="50000"/>
+                <a:satMod val="300000"/>
+              </a:schemeClr>
+            </a:gs>
+            <a:gs pos="35000">
+              <a:schemeClr val="phClr">
+                <a:tint val="37000"/>
+                <a:satMod val="300000"/>
+              </a:schemeClr>
+            </a:gs>
+            <a:gs pos="100000">
+              <a:schemeClr val="phClr">
+                <a:tint val="15000"/>
+                <a:satMod val="350000"/>
+              </a:schemeClr>
+            </a:gs>
+          </a:gsLst>
+          <a:lin ang="16200000" scaled="1"/>
+        </a:gradFill>
+        <a:gradFill rotWithShape="1">
+          <a:gsLst>
+            <a:gs pos="0">
+              <a:schemeClr val="phClr">
+                <a:tint val="100000"/>
+                <a:shade val="100000"/>
+                <a:satMod val="130000"/>
+              </a:schemeClr>
+            </a:gs>
+            <a:gs pos="100000">
+              <a:schemeClr val="phClr">
+                <a:tint val="50000"/>
+                <a:shade val="100000"/>
+                <a:satMod val="350000"/>
+              </a:schemeClr>
+            </a:gs>
+          </a:gsLst>
+          <a:lin ang="16200000" scaled="0"/>
+        </a:gradFill>
+      </a:fillStyleLst>
+      <a:lnStyleLst>
+        <a:ln w="9525" cap="flat" cmpd="sng" algn="ctr">
+          <a:solidFill>
+            <a:schemeClr val="phClr">
+              <a:shade val="95000"/>
+              <a:satMod val="105000"/>
+            </a:schemeClr>
+          </a:solidFill>
+          <a:prstDash val="solid"/>
+        </a:ln>
+        <a:ln w="25400" cap="flat" cmpd="sng" algn="ctr">
+          <a:solidFill>
+            <a:schemeClr val="phClr"/>
+          </a:solidFill>
+          <a:prstDash val="solid"/>
+        </a:ln>
+        <a:ln w="38100" cap="flat" cmpd="sng" algn="ctr">
+          <a:solidFill>
+            <a:schemeClr val="phClr"/>
+          </a:solidFill>
+          <a:prstDash val="solid"/>
+        </a:ln>
+      </a:lnStyleLst>
+      <a:effectStyleLst>
+        <a:effectStyle>
+          <a:effectLst>
+            <a:outerShdw blurRad="40000" dist="20000" dir="5400000" rotWithShape="0">
+              <a:srgbClr val="000000">
+                <a:alpha val="38000"/>
+              </a:srgbClr>
+            </a:outerShdw>
+          </a:effectLst>
+        </a:effectStyle>
+        <a:effectStyle>
+          <a:effectLst>
+            <a:outerShdw blurRad="40000" dist="23000" dir="5400000" rotWithShape="0">
+              <a:srgbClr val="000000">
+                <a:alpha val="35000"/>
+              </a:srgbClr>
+            </a:outerShdw>
+          </a:effectLst>
+        </a:effectStyle>
+        <a:effectStyle>
+          <a:effectLst>
+            <a:outerShdw blurRad="40000" dist="23000" dir="5400000" rotWithShape="0">
+              <a:srgbClr val="000000">
+                <a:alpha val="35000"/>
+              </a:srgbClr>
+            </a:outerShdw>
+          </a:effectLst>
+          <a:scene3d>
+            <a:camera prst="orthographicFront">
+              <a:rot lat="0" lon="0" rev="0"/>
+            </a:camera>
+            <a:lightRig rig="threePt" dir="t">
+              <a:rot lat="0" lon="0" rev="1200000"/>
+            </a:lightRig>
+          </a:scene3d>
+          <a:sp3d>
+            <a:bevelT w="63500" h="25400"/>
+          </a:sp3d>
+        </a:effectStyle>
+      </a:effectStyleLst>
+      <a:bgFillStyleLst>
+        <a:solidFill>
+          <a:schemeClr val="phClr"/>
+        </a:solidFill>
+        <a:gradFill rotWithShape="1">
+          <a:gsLst>
+            <a:gs pos="0">
+              <a:schemeClr val="phClr">
+                <a:tint val="40000"/>
+                <a:satMod val="350000"/>
+              </a:schemeClr>
+            </a:gs>
+            <a:gs pos="40000">
+              <a:schemeClr val="phClr">
+                <a:tint val="45000"/>
+                <a:shade val="99000"/>
+                <a:satMod val="350000"/>
+              </a:schemeClr>
+            </a:gs>
+            <a:gs pos="100000">
+              <a:schemeClr val="phClr">
+                <a:shade val="20000"/>
+                <a:satMod val="255000"/>
+              </a:schemeClr>
+            </a:gs>
+          </a:gsLst>
+          <a:path path="circle">
+            <a:fillToRect l="50000" t="-80000" r="50000" b="180000"/>
+          </a:path>
+        </a:gradFill>
+        <a:gradFill rotWithShape="1">
+          <a:gsLst>
+            <a:gs pos="0">
+              <a:schemeClr val="phClr">
+                <a:tint val="80000"/>
+                <a:satMod val="300000"/>
+              </a:schemeClr>
+            </a:gs>
+            <a:gs pos="100000">
+              <a:schemeClr val="phClr">
+                <a:shade val="30000"/>
+                <a:satMod val="200000"/>
+              </a:schemeClr>
+            </a:gs>
+          </a:gsLst>
+          <a:path path="circle">
+            <a:fillToRect l="50000" t="50000" r="50000" b="50000"/>
+          </a:path>
+        </a:gradFill>
+      </a:bgFillStyleLst>
+    </a:fmtScheme>
+  </a:themeElements>
+  <a:objectDefaults>
+    <a:spDef>
+      <a:spPr/>
+      <a:bodyPr/>
+      <a:lstStyle/>
+      <a:style>
+        <a:lnRef idx="1">
+          <a:schemeClr val="accent1"/>
+        </a:lnRef>
+        <a:fillRef idx="3">
+          <a:schemeClr val="accent1"/>
+        </a:fillRef>
+        <a:effectRef idx="2">
+          <a:schemeClr val="accent1"/>
+        </a:effectRef>
+        <a:fontRef idx="minor">
+          <a:schemeClr val="lt1"/>
+        </a:fontRef>
+      </a:style>
+    </a:spDef>
+    <a:lnDef>
+      <a:spPr/>
+      <a:bodyPr/>
+      <a:lstStyle/>
+      <a:style>
+        <a:lnRef idx="2">
+          <a:schemeClr val="accent1"/>
+        </a:lnRef>
+        <a:fillRef idx="0">
+          <a:schemeClr val="accent1"/>
+        </a:fillRef>
+        <a:effectRef idx="1">
+          <a:schemeClr val="accent1"/>
+        </a:effectRef>
+        <a:fontRef idx="minor">
+          <a:schemeClr val="tx1"/>
+        </a:fontRef>
+      </a:style>
+    </a:lnDef>
+  </a:objectDefaults>
+  <a:extraClrSchemeLst/>
+</a:theme>
 </file>
</xml_diff>